<commit_message>
week 3 lectures and problemsets
</commit_message>
<xml_diff>
--- a/lectures/week_2/Grammar.pptx
+++ b/lectures/week_2/Grammar.pptx
@@ -5,7 +5,7 @@
     <p:sldMasterId id="2147483659" r:id="rId1"/>
   </p:sldMasterIdLst>
   <p:notesMasterIdLst>
-    <p:notesMasterId r:id="rId22"/>
+    <p:notesMasterId r:id="rId25"/>
   </p:notesMasterIdLst>
   <p:sldIdLst>
     <p:sldId id="256" r:id="rId2"/>
@@ -14,44 +14,47 @@
     <p:sldId id="259" r:id="rId5"/>
     <p:sldId id="260" r:id="rId6"/>
     <p:sldId id="261" r:id="rId7"/>
-    <p:sldId id="262" r:id="rId8"/>
-    <p:sldId id="263" r:id="rId9"/>
-    <p:sldId id="264" r:id="rId10"/>
-    <p:sldId id="265" r:id="rId11"/>
-    <p:sldId id="266" r:id="rId12"/>
-    <p:sldId id="267" r:id="rId13"/>
-    <p:sldId id="268" r:id="rId14"/>
-    <p:sldId id="269" r:id="rId15"/>
-    <p:sldId id="270" r:id="rId16"/>
-    <p:sldId id="271" r:id="rId17"/>
-    <p:sldId id="272" r:id="rId18"/>
-    <p:sldId id="273" r:id="rId19"/>
-    <p:sldId id="274" r:id="rId20"/>
-    <p:sldId id="275" r:id="rId21"/>
+    <p:sldId id="276" r:id="rId8"/>
+    <p:sldId id="262" r:id="rId9"/>
+    <p:sldId id="263" r:id="rId10"/>
+    <p:sldId id="264" r:id="rId11"/>
+    <p:sldId id="265" r:id="rId12"/>
+    <p:sldId id="266" r:id="rId13"/>
+    <p:sldId id="267" r:id="rId14"/>
+    <p:sldId id="268" r:id="rId15"/>
+    <p:sldId id="269" r:id="rId16"/>
+    <p:sldId id="270" r:id="rId17"/>
+    <p:sldId id="277" r:id="rId18"/>
+    <p:sldId id="278" r:id="rId19"/>
+    <p:sldId id="271" r:id="rId20"/>
+    <p:sldId id="272" r:id="rId21"/>
+    <p:sldId id="273" r:id="rId22"/>
+    <p:sldId id="274" r:id="rId23"/>
+    <p:sldId id="275" r:id="rId24"/>
   </p:sldIdLst>
   <p:sldSz cx="9144000" cy="5143500" type="screen16x9"/>
   <p:notesSz cx="6858000" cy="9144000"/>
   <p:embeddedFontLst>
     <p:embeddedFont>
       <p:font typeface="Lato" panose="020F0502020204030203" pitchFamily="34" charset="0"/>
-      <p:regular r:id="rId23"/>
-      <p:bold r:id="rId24"/>
-      <p:italic r:id="rId25"/>
-      <p:boldItalic r:id="rId26"/>
+      <p:regular r:id="rId26"/>
+      <p:bold r:id="rId27"/>
+      <p:italic r:id="rId28"/>
+      <p:boldItalic r:id="rId29"/>
     </p:embeddedFont>
     <p:embeddedFont>
       <p:font typeface="Raleway" pitchFamily="2" charset="77"/>
-      <p:regular r:id="rId27"/>
-      <p:bold r:id="rId28"/>
-      <p:italic r:id="rId29"/>
-      <p:boldItalic r:id="rId30"/>
+      <p:regular r:id="rId30"/>
+      <p:bold r:id="rId31"/>
+      <p:italic r:id="rId32"/>
+      <p:boldItalic r:id="rId33"/>
     </p:embeddedFont>
     <p:embeddedFont>
       <p:font typeface="Roboto Mono" pitchFamily="49" charset="0"/>
-      <p:regular r:id="rId31"/>
-      <p:bold r:id="rId32"/>
-      <p:italic r:id="rId33"/>
-      <p:boldItalic r:id="rId34"/>
+      <p:regular r:id="rId34"/>
+      <p:bold r:id="rId35"/>
+      <p:italic r:id="rId36"/>
+      <p:boldItalic r:id="rId37"/>
     </p:embeddedFont>
   </p:embeddedFontLst>
   <p:defaultTextStyle>
@@ -1188,7 +1191,7 @@
         </p:nvSpPr>
         <p:spPr>
           <a:xfrm>
-            <a:off x="381300" y="685800"/>
+            <a:off x="381000" y="685800"/>
             <a:ext cx="6096000" cy="3429000"/>
           </a:xfrm>
           <a:custGeom>
@@ -1916,7 +1919,7 @@
         </p:nvSpPr>
         <p:spPr>
           <a:xfrm>
-            <a:off x="381300" y="685800"/>
+            <a:off x="381000" y="685800"/>
             <a:ext cx="6096000" cy="3429000"/>
           </a:xfrm>
           <a:custGeom>
@@ -2228,7 +2231,7 @@
         </p:nvSpPr>
         <p:spPr>
           <a:xfrm>
-            <a:off x="381300" y="685800"/>
+            <a:off x="381000" y="685800"/>
             <a:ext cx="6096000" cy="3429000"/>
           </a:xfrm>
           <a:custGeom>
@@ -2332,7 +2335,7 @@
         </p:nvSpPr>
         <p:spPr>
           <a:xfrm>
-            <a:off x="381300" y="685800"/>
+            <a:off x="381000" y="685800"/>
             <a:ext cx="6096000" cy="3429000"/>
           </a:xfrm>
           <a:custGeom>
@@ -2436,7 +2439,7 @@
         </p:nvSpPr>
         <p:spPr>
           <a:xfrm>
-            <a:off x="381300" y="685800"/>
+            <a:off x="381000" y="685800"/>
             <a:ext cx="6096000" cy="3429000"/>
           </a:xfrm>
           <a:custGeom>
@@ -2644,7 +2647,7 @@
         </p:nvSpPr>
         <p:spPr>
           <a:xfrm>
-            <a:off x="381300" y="685800"/>
+            <a:off x="381000" y="685800"/>
             <a:ext cx="6096000" cy="3429000"/>
           </a:xfrm>
           <a:custGeom>
@@ -9259,6 +9262,332 @@
   <p:cSld>
     <p:spTree>
       <p:nvGrpSpPr>
+        <p:cNvPr id="1" name="Shape 133"/>
+        <p:cNvGrpSpPr/>
+        <p:nvPr/>
+      </p:nvGrpSpPr>
+      <p:grpSpPr>
+        <a:xfrm>
+          <a:off x="0" y="0"/>
+          <a:ext cx="0" cy="0"/>
+          <a:chOff x="0" y="0"/>
+          <a:chExt cx="0" cy="0"/>
+        </a:xfrm>
+      </p:grpSpPr>
+      <p:sp>
+        <p:nvSpPr>
+          <p:cNvPr id="134" name="Google Shape;134;p21"/>
+          <p:cNvSpPr txBox="1">
+            <a:spLocks noGrp="1"/>
+          </p:cNvSpPr>
+          <p:nvPr>
+            <p:ph type="title"/>
+          </p:nvPr>
+        </p:nvSpPr>
+        <p:spPr>
+          <a:xfrm>
+            <a:off x="729450" y="1318650"/>
+            <a:ext cx="7688700" cy="535200"/>
+          </a:xfrm>
+          <a:prstGeom prst="rect">
+            <a:avLst/>
+          </a:prstGeom>
+        </p:spPr>
+        <p:txBody>
+          <a:bodyPr spcFirstLastPara="1" wrap="square" lIns="91425" tIns="91425" rIns="91425" bIns="91425" anchor="t" anchorCtr="0">
+            <a:normAutofit fontScale="90000"/>
+          </a:bodyPr>
+          <a:lstStyle/>
+          <a:p>
+            <a:pPr marL="0" lvl="0" indent="0" algn="l" rtl="0">
+              <a:spcBef>
+                <a:spcPts val="0"/>
+              </a:spcBef>
+              <a:spcAft>
+                <a:spcPts val="0"/>
+              </a:spcAft>
+              <a:buNone/>
+            </a:pPr>
+            <a:r>
+              <a:rPr lang="en"/>
+              <a:t>An Example: Bits</a:t>
+            </a:r>
+            <a:endParaRPr/>
+          </a:p>
+        </p:txBody>
+      </p:sp>
+      <p:sp>
+        <p:nvSpPr>
+          <p:cNvPr id="135" name="Google Shape;135;p21"/>
+          <p:cNvSpPr txBox="1">
+            <a:spLocks noGrp="1"/>
+          </p:cNvSpPr>
+          <p:nvPr>
+            <p:ph type="body" idx="1"/>
+          </p:nvPr>
+        </p:nvSpPr>
+        <p:spPr>
+          <a:xfrm>
+            <a:off x="729449" y="2078875"/>
+            <a:ext cx="2227395" cy="2261100"/>
+          </a:xfrm>
+          <a:prstGeom prst="rect">
+            <a:avLst/>
+          </a:prstGeom>
+        </p:spPr>
+        <p:txBody>
+          <a:bodyPr spcFirstLastPara="1" wrap="square" lIns="91425" tIns="91425" rIns="91425" bIns="91425" anchor="t" anchorCtr="0">
+            <a:normAutofit/>
+          </a:bodyPr>
+          <a:lstStyle/>
+          <a:p>
+            <a:pPr marL="0" lvl="0" indent="0" algn="l" rtl="0">
+              <a:spcBef>
+                <a:spcPts val="0"/>
+              </a:spcBef>
+              <a:spcAft>
+                <a:spcPts val="0"/>
+              </a:spcAft>
+              <a:buNone/>
+            </a:pPr>
+            <a:r>
+              <a:rPr lang="en" sz="1600" i="1" dirty="0"/>
+              <a:t>Bit</a:t>
+            </a:r>
+            <a:r>
+              <a:rPr lang="en" sz="1600" dirty="0"/>
+              <a:t> 	=&gt; 	0</a:t>
+            </a:r>
+          </a:p>
+          <a:p>
+            <a:pPr marL="0" lvl="0" indent="0" algn="l" rtl="0">
+              <a:spcBef>
+                <a:spcPts val="0"/>
+              </a:spcBef>
+              <a:spcAft>
+                <a:spcPts val="0"/>
+              </a:spcAft>
+              <a:buNone/>
+            </a:pPr>
+            <a:r>
+              <a:rPr lang="en" sz="1600" dirty="0"/>
+              <a:t>	|	1</a:t>
+            </a:r>
+            <a:endParaRPr sz="1600" dirty="0"/>
+          </a:p>
+          <a:p>
+            <a:pPr marL="0" lvl="0" indent="0" algn="l" rtl="0">
+              <a:spcBef>
+                <a:spcPts val="1200"/>
+              </a:spcBef>
+              <a:spcAft>
+                <a:spcPts val="0"/>
+              </a:spcAft>
+              <a:buNone/>
+            </a:pPr>
+            <a:endParaRPr sz="1600" dirty="0"/>
+          </a:p>
+          <a:p>
+            <a:pPr marL="0" lvl="0" indent="0" algn="l" rtl="0">
+              <a:spcBef>
+                <a:spcPts val="1200"/>
+              </a:spcBef>
+              <a:spcAft>
+                <a:spcPts val="1200"/>
+              </a:spcAft>
+              <a:buNone/>
+            </a:pPr>
+            <a:endParaRPr sz="1600" dirty="0"/>
+          </a:p>
+        </p:txBody>
+      </p:sp>
+      <p:sp>
+        <p:nvSpPr>
+          <p:cNvPr id="136" name="Google Shape;136;p21"/>
+          <p:cNvSpPr txBox="1"/>
+          <p:nvPr/>
+        </p:nvSpPr>
+        <p:spPr>
+          <a:xfrm>
+            <a:off x="4196750" y="2142825"/>
+            <a:ext cx="4221300" cy="2646300"/>
+          </a:xfrm>
+          <a:prstGeom prst="rect">
+            <a:avLst/>
+          </a:prstGeom>
+          <a:noFill/>
+          <a:ln>
+            <a:noFill/>
+          </a:ln>
+        </p:spPr>
+        <p:txBody>
+          <a:bodyPr spcFirstLastPara="1" wrap="square" lIns="91425" tIns="91425" rIns="91425" bIns="91425" anchor="t" anchorCtr="0">
+            <a:noAutofit/>
+          </a:bodyPr>
+          <a:lstStyle/>
+          <a:p>
+            <a:pPr marL="457200" lvl="0" indent="-330200" algn="l" rtl="0">
+              <a:spcBef>
+                <a:spcPts val="0"/>
+              </a:spcBef>
+              <a:spcAft>
+                <a:spcPts val="0"/>
+              </a:spcAft>
+              <a:buClr>
+                <a:schemeClr val="accent1"/>
+              </a:buClr>
+              <a:buSzPts val="1600"/>
+              <a:buFont typeface="Lato"/>
+              <a:buChar char="-"/>
+            </a:pPr>
+            <a:r>
+              <a:rPr lang="en" sz="1600" dirty="0">
+                <a:solidFill>
+                  <a:schemeClr val="accent1"/>
+                </a:solidFill>
+                <a:latin typeface="Lato"/>
+                <a:ea typeface="Lato"/>
+                <a:cs typeface="Lato"/>
+                <a:sym typeface="Lato"/>
+              </a:rPr>
+              <a:t>Only one rule</a:t>
+            </a:r>
+            <a:endParaRPr sz="1600" dirty="0">
+              <a:solidFill>
+                <a:schemeClr val="accent1"/>
+              </a:solidFill>
+              <a:latin typeface="Lato"/>
+              <a:ea typeface="Lato"/>
+              <a:cs typeface="Lato"/>
+              <a:sym typeface="Lato"/>
+            </a:endParaRPr>
+          </a:p>
+          <a:p>
+            <a:pPr marL="457200" lvl="0" indent="-330200" algn="l" rtl="0">
+              <a:spcBef>
+                <a:spcPts val="0"/>
+              </a:spcBef>
+              <a:spcAft>
+                <a:spcPts val="0"/>
+              </a:spcAft>
+              <a:buClr>
+                <a:schemeClr val="accent1"/>
+              </a:buClr>
+              <a:buSzPts val="1600"/>
+              <a:buFont typeface="Lato"/>
+              <a:buChar char="-"/>
+            </a:pPr>
+            <a:r>
+              <a:rPr lang="en" sz="1600" dirty="0">
+                <a:solidFill>
+                  <a:schemeClr val="accent1"/>
+                </a:solidFill>
+                <a:latin typeface="Lato"/>
+                <a:ea typeface="Lato"/>
+                <a:cs typeface="Lato"/>
+                <a:sym typeface="Lato"/>
+              </a:rPr>
+              <a:t>One non-terminal</a:t>
+            </a:r>
+            <a:endParaRPr sz="1600" dirty="0">
+              <a:solidFill>
+                <a:schemeClr val="accent1"/>
+              </a:solidFill>
+              <a:latin typeface="Lato"/>
+              <a:ea typeface="Lato"/>
+              <a:cs typeface="Lato"/>
+              <a:sym typeface="Lato"/>
+            </a:endParaRPr>
+          </a:p>
+          <a:p>
+            <a:pPr marL="457200" lvl="0" indent="-330200" algn="l" rtl="0">
+              <a:spcBef>
+                <a:spcPts val="0"/>
+              </a:spcBef>
+              <a:spcAft>
+                <a:spcPts val="0"/>
+              </a:spcAft>
+              <a:buClr>
+                <a:schemeClr val="accent1"/>
+              </a:buClr>
+              <a:buSzPts val="1600"/>
+              <a:buFont typeface="Lato"/>
+              <a:buChar char="-"/>
+            </a:pPr>
+            <a:r>
+              <a:rPr lang="en" sz="1600" dirty="0">
+                <a:solidFill>
+                  <a:schemeClr val="accent1"/>
+                </a:solidFill>
+                <a:latin typeface="Lato"/>
+                <a:ea typeface="Lato"/>
+                <a:cs typeface="Lato"/>
+                <a:sym typeface="Lato"/>
+              </a:rPr>
+              <a:t>Two terminals</a:t>
+            </a:r>
+            <a:endParaRPr sz="1600" dirty="0">
+              <a:solidFill>
+                <a:schemeClr val="accent1"/>
+              </a:solidFill>
+              <a:latin typeface="Lato"/>
+              <a:ea typeface="Lato"/>
+              <a:cs typeface="Lato"/>
+              <a:sym typeface="Lato"/>
+            </a:endParaRPr>
+          </a:p>
+          <a:p>
+            <a:pPr marL="457200" lvl="0" indent="-330200" algn="l" rtl="0">
+              <a:spcBef>
+                <a:spcPts val="0"/>
+              </a:spcBef>
+              <a:spcAft>
+                <a:spcPts val="0"/>
+              </a:spcAft>
+              <a:buClr>
+                <a:schemeClr val="accent1"/>
+              </a:buClr>
+              <a:buSzPts val="1600"/>
+              <a:buFont typeface="Lato"/>
+              <a:buChar char="-"/>
+            </a:pPr>
+            <a:r>
+              <a:rPr lang="en" sz="1600" dirty="0">
+                <a:solidFill>
+                  <a:schemeClr val="accent1"/>
+                </a:solidFill>
+                <a:latin typeface="Lato"/>
+                <a:ea typeface="Lato"/>
+                <a:cs typeface="Lato"/>
+                <a:sym typeface="Lato"/>
+              </a:rPr>
+              <a:t>How many sentences can we make with this grammar?</a:t>
+            </a:r>
+            <a:endParaRPr sz="1600" dirty="0">
+              <a:solidFill>
+                <a:schemeClr val="accent1"/>
+              </a:solidFill>
+              <a:latin typeface="Lato"/>
+              <a:ea typeface="Lato"/>
+              <a:cs typeface="Lato"/>
+              <a:sym typeface="Lato"/>
+            </a:endParaRPr>
+          </a:p>
+        </p:txBody>
+      </p:sp>
+    </p:spTree>
+  </p:cSld>
+  <p:clrMapOvr>
+    <a:masterClrMapping/>
+  </p:clrMapOvr>
+</p:sld>
+</file>
+
+<file path=ppt/slides/slide11.xml><?xml version="1.0" encoding="utf-8"?>
+<p:sld xmlns:a="http://schemas.openxmlformats.org/drawingml/2006/main" xmlns:r="http://schemas.openxmlformats.org/officeDocument/2006/relationships" xmlns:p="http://schemas.openxmlformats.org/presentationml/2006/main">
+  <p:cSld>
+    <p:spTree>
+      <p:nvGrpSpPr>
         <p:cNvPr id="1" name="Shape 140"/>
         <p:cNvGrpSpPr/>
         <p:nvPr/>
@@ -9737,7 +10066,7 @@
 </p:sld>
 </file>
 
-<file path=ppt/slides/slide11.xml><?xml version="1.0" encoding="utf-8"?>
+<file path=ppt/slides/slide12.xml><?xml version="1.0" encoding="utf-8"?>
 <p:sld xmlns:a="http://schemas.openxmlformats.org/drawingml/2006/main" xmlns:r="http://schemas.openxmlformats.org/officeDocument/2006/relationships" xmlns:p="http://schemas.openxmlformats.org/presentationml/2006/main">
   <p:cSld>
     <p:spTree>
@@ -9992,7 +10321,7 @@
 </p:sld>
 </file>
 
-<file path=ppt/slides/slide12.xml><?xml version="1.0" encoding="utf-8"?>
+<file path=ppt/slides/slide13.xml><?xml version="1.0" encoding="utf-8"?>
 <p:sld xmlns:a="http://schemas.openxmlformats.org/drawingml/2006/main" xmlns:r="http://schemas.openxmlformats.org/officeDocument/2006/relationships" xmlns:p="http://schemas.openxmlformats.org/presentationml/2006/main">
   <p:cSld>
     <p:spTree>
@@ -10153,7 +10482,7 @@
 </p:sld>
 </file>
 
-<file path=ppt/slides/slide13.xml><?xml version="1.0" encoding="utf-8"?>
+<file path=ppt/slides/slide14.xml><?xml version="1.0" encoding="utf-8"?>
 <p:sld xmlns:a="http://schemas.openxmlformats.org/drawingml/2006/main" xmlns:r="http://schemas.openxmlformats.org/officeDocument/2006/relationships" xmlns:p="http://schemas.openxmlformats.org/presentationml/2006/main">
   <p:cSld>
     <p:spTree>
@@ -10205,10 +10534,10 @@
               <a:buNone/>
             </a:pPr>
             <a:r>
-              <a:rPr lang="en"/>
-              <a:t>BNF for a language with n a’s, followed by n b’s</a:t>
-            </a:r>
-            <a:endParaRPr/>
+              <a:rPr lang="en" dirty="0"/>
+              <a:t>BNF for a language with n a’s</a:t>
+            </a:r>
+            <a:endParaRPr dirty="0"/>
           </a:p>
         </p:txBody>
       </p:sp>
@@ -10233,7 +10562,7 @@
         </p:spPr>
         <p:txBody>
           <a:bodyPr spcFirstLastPara="1" wrap="square" lIns="91425" tIns="91425" rIns="91425" bIns="91425" anchor="t" anchorCtr="0">
-            <a:normAutofit/>
+            <a:normAutofit fontScale="92500" lnSpcReduction="10000"/>
           </a:bodyPr>
           <a:lstStyle/>
           <a:p>
@@ -10247,18 +10576,26 @@
               <a:buNone/>
             </a:pPr>
             <a:r>
-              <a:rPr lang="en" sz="1600"/>
-              <a:t>We might express this language as {a</a:t>
-            </a:r>
-            <a:r>
-              <a:rPr lang="en" sz="1600" baseline="30000"/>
+              <a:rPr lang="en" sz="1600" dirty="0"/>
+              <a:t>We might express this language as {</a:t>
+            </a:r>
+            <a:r>
+              <a:rPr lang="en" sz="1600" dirty="0" err="1"/>
+              <a:t>a</a:t>
+            </a:r>
+            <a:r>
+              <a:rPr lang="en" sz="1600" baseline="30000" dirty="0" err="1"/>
               <a:t>n</a:t>
             </a:r>
             <a:r>
-              <a:rPr lang="en" sz="1600"/>
-              <a:t>|n ∈ N, n &gt;= 0} . . . but what would this look like in BNF?</a:t>
-            </a:r>
-            <a:endParaRPr sz="1600"/>
+              <a:rPr lang="en" sz="1600" dirty="0" err="1"/>
+              <a:t>|n</a:t>
+            </a:r>
+            <a:r>
+              <a:rPr lang="en" sz="1600" dirty="0"/>
+              <a:t> ∈ N, n &gt;= 0} . . . but what would this look like in BNF?</a:t>
+            </a:r>
+            <a:endParaRPr sz="1600" dirty="0"/>
           </a:p>
           <a:p>
             <a:pPr marL="0" lvl="0" indent="0" algn="l" rtl="0">
@@ -10271,10 +10608,9 @@
               <a:buNone/>
             </a:pPr>
             <a:r>
-              <a:rPr lang="en" sz="1600"/>
+              <a:rPr lang="en" sz="1600" dirty="0"/>
               <a:t>There are a lot of options</a:t>
             </a:r>
-            <a:endParaRPr sz="1600"/>
           </a:p>
           <a:p>
             <a:pPr marL="0" lvl="0" indent="0" algn="l" rtl="0">
@@ -10282,11 +10618,45 @@
                 <a:spcPts val="1200"/>
               </a:spcBef>
               <a:spcAft>
+                <a:spcPts val="0"/>
+              </a:spcAft>
+              <a:buNone/>
+            </a:pPr>
+            <a:r>
+              <a:rPr lang="en" sz="1600" dirty="0"/>
+              <a:t>Keep in mind, our BNF grammar </a:t>
+            </a:r>
+            <a:r>
+              <a:rPr lang="en" sz="1600" i="1" dirty="0"/>
+              <a:t>must be an exact fit</a:t>
+            </a:r>
+            <a:r>
+              <a:rPr lang="en" sz="1600" dirty="0"/>
+              <a:t>.  It needs to:</a:t>
+            </a:r>
+          </a:p>
+          <a:p>
+            <a:pPr marL="285750" indent="-285750">
+              <a:spcBef>
                 <a:spcPts val="1200"/>
-              </a:spcAft>
-              <a:buNone/>
-            </a:pPr>
-            <a:endParaRPr sz="1600"/>
+              </a:spcBef>
+            </a:pPr>
+            <a:r>
+              <a:rPr lang="en" sz="1600" dirty="0"/>
+              <a:t>Describe all potential sentences in this language</a:t>
+            </a:r>
+          </a:p>
+          <a:p>
+            <a:pPr marL="285750" indent="-285750">
+              <a:spcBef>
+                <a:spcPts val="1200"/>
+              </a:spcBef>
+            </a:pPr>
+            <a:r>
+              <a:rPr lang="en" sz="1600" dirty="0"/>
+              <a:t>Not describe any sentences outside of this language</a:t>
+            </a:r>
+            <a:endParaRPr sz="1600" dirty="0"/>
           </a:p>
         </p:txBody>
       </p:sp>
@@ -10298,7 +10668,7 @@
 </p:sld>
 </file>
 
-<file path=ppt/slides/slide14.xml><?xml version="1.0" encoding="utf-8"?>
+<file path=ppt/slides/slide15.xml><?xml version="1.0" encoding="utf-8"?>
 <p:sld xmlns:a="http://schemas.openxmlformats.org/drawingml/2006/main" xmlns:r="http://schemas.openxmlformats.org/officeDocument/2006/relationships" xmlns:p="http://schemas.openxmlformats.org/presentationml/2006/main">
   <p:cSld>
     <p:spTree>
@@ -10639,7 +11009,7 @@
 </p:sld>
 </file>
 
-<file path=ppt/slides/slide15.xml><?xml version="1.0" encoding="utf-8"?>
+<file path=ppt/slides/slide16.xml><?xml version="1.0" encoding="utf-8"?>
 <p:sld xmlns:a="http://schemas.openxmlformats.org/drawingml/2006/main" xmlns:r="http://schemas.openxmlformats.org/officeDocument/2006/relationships" xmlns:p="http://schemas.openxmlformats.org/presentationml/2006/main">
   <p:cSld>
     <p:spTree>
@@ -10972,7 +11342,588 @@
 </p:sld>
 </file>
 
-<file path=ppt/slides/slide16.xml><?xml version="1.0" encoding="utf-8"?>
+<file path=ppt/slides/slide17.xml><?xml version="1.0" encoding="utf-8"?>
+<p:sld xmlns:a="http://schemas.openxmlformats.org/drawingml/2006/main" xmlns:r="http://schemas.openxmlformats.org/officeDocument/2006/relationships" xmlns:p="http://schemas.openxmlformats.org/presentationml/2006/main">
+  <p:cSld>
+    <p:spTree>
+      <p:nvGrpSpPr>
+        <p:cNvPr id="1" name=""/>
+        <p:cNvGrpSpPr/>
+        <p:nvPr/>
+      </p:nvGrpSpPr>
+      <p:grpSpPr>
+        <a:xfrm>
+          <a:off x="0" y="0"/>
+          <a:ext cx="0" cy="0"/>
+          <a:chOff x="0" y="0"/>
+          <a:chExt cx="0" cy="0"/>
+        </a:xfrm>
+      </p:grpSpPr>
+      <p:sp>
+        <p:nvSpPr>
+          <p:cNvPr id="2" name="Title 1">
+            <a:extLst>
+              <a:ext uri="{FF2B5EF4-FFF2-40B4-BE49-F238E27FC236}">
+                <a16:creationId xmlns:a16="http://schemas.microsoft.com/office/drawing/2014/main" id="{C9157CC2-3D10-C163-0505-095FB90B448C}"/>
+              </a:ext>
+            </a:extLst>
+          </p:cNvPr>
+          <p:cNvSpPr>
+            <a:spLocks noGrp="1"/>
+          </p:cNvSpPr>
+          <p:nvPr>
+            <p:ph type="title"/>
+          </p:nvPr>
+        </p:nvSpPr>
+        <p:spPr/>
+        <p:txBody>
+          <a:bodyPr>
+            <a:normAutofit fontScale="90000"/>
+          </a:bodyPr>
+          <a:lstStyle/>
+          <a:p>
+            <a:r>
+              <a:rPr lang="en" dirty="0"/>
+              <a:t>BNF for a language with n a’s followed by a b</a:t>
+            </a:r>
+            <a:endParaRPr lang="en-US" dirty="0"/>
+          </a:p>
+        </p:txBody>
+      </p:sp>
+      <p:sp>
+        <p:nvSpPr>
+          <p:cNvPr id="3" name="Text Placeholder 2">
+            <a:extLst>
+              <a:ext uri="{FF2B5EF4-FFF2-40B4-BE49-F238E27FC236}">
+                <a16:creationId xmlns:a16="http://schemas.microsoft.com/office/drawing/2014/main" id="{84FCCCC5-E2C6-0A8A-400C-659EC67A773E}"/>
+              </a:ext>
+            </a:extLst>
+          </p:cNvPr>
+          <p:cNvSpPr>
+            <a:spLocks noGrp="1"/>
+          </p:cNvSpPr>
+          <p:nvPr>
+            <p:ph type="body" idx="1"/>
+          </p:nvPr>
+        </p:nvSpPr>
+        <p:spPr/>
+        <p:txBody>
+          <a:bodyPr>
+            <a:normAutofit/>
+          </a:bodyPr>
+          <a:lstStyle/>
+          <a:p>
+            <a:pPr marL="0" lvl="0" indent="0">
+              <a:buNone/>
+            </a:pPr>
+            <a:r>
+              <a:rPr lang="en-US" sz="1600" dirty="0"/>
+              <a:t>We might express this language as {</a:t>
+            </a:r>
+            <a:r>
+              <a:rPr lang="en-US" sz="1600" dirty="0" err="1"/>
+              <a:t>a</a:t>
+            </a:r>
+            <a:r>
+              <a:rPr lang="en-US" sz="1600" baseline="30000" dirty="0" err="1"/>
+              <a:t>n</a:t>
+            </a:r>
+            <a:r>
+              <a:rPr lang="en-US" sz="1600" dirty="0" err="1"/>
+              <a:t>b|n</a:t>
+            </a:r>
+            <a:r>
+              <a:rPr lang="en-US" sz="1600" dirty="0"/>
+              <a:t> ∈ N, n &gt;= 0} . . . but what would this look like in BNF?</a:t>
+            </a:r>
+          </a:p>
+          <a:p>
+            <a:pPr marL="0" lvl="0" indent="0">
+              <a:spcBef>
+                <a:spcPts val="1200"/>
+              </a:spcBef>
+              <a:buNone/>
+            </a:pPr>
+            <a:r>
+              <a:rPr lang="en-US" sz="1600" dirty="0"/>
+              <a:t>There are a lot of options</a:t>
+            </a:r>
+          </a:p>
+          <a:p>
+            <a:endParaRPr lang="en-US" sz="1600" dirty="0"/>
+          </a:p>
+        </p:txBody>
+      </p:sp>
+    </p:spTree>
+    <p:extLst>
+      <p:ext uri="{BB962C8B-B14F-4D97-AF65-F5344CB8AC3E}">
+        <p14:creationId xmlns:p14="http://schemas.microsoft.com/office/powerpoint/2010/main" val="3871233720"/>
+      </p:ext>
+    </p:extLst>
+  </p:cSld>
+  <p:clrMapOvr>
+    <a:masterClrMapping/>
+  </p:clrMapOvr>
+</p:sld>
+</file>
+
+<file path=ppt/slides/slide18.xml><?xml version="1.0" encoding="utf-8"?>
+<p:sld xmlns:a="http://schemas.openxmlformats.org/drawingml/2006/main" xmlns:r="http://schemas.openxmlformats.org/officeDocument/2006/relationships" xmlns:p="http://schemas.openxmlformats.org/presentationml/2006/main">
+  <p:cSld>
+    <p:spTree>
+      <p:nvGrpSpPr>
+        <p:cNvPr id="1" name=""/>
+        <p:cNvGrpSpPr/>
+        <p:nvPr/>
+      </p:nvGrpSpPr>
+      <p:grpSpPr>
+        <a:xfrm>
+          <a:off x="0" y="0"/>
+          <a:ext cx="0" cy="0"/>
+          <a:chOff x="0" y="0"/>
+          <a:chExt cx="0" cy="0"/>
+        </a:xfrm>
+      </p:grpSpPr>
+      <p:sp>
+        <p:nvSpPr>
+          <p:cNvPr id="2" name="Title 1">
+            <a:extLst>
+              <a:ext uri="{FF2B5EF4-FFF2-40B4-BE49-F238E27FC236}">
+                <a16:creationId xmlns:a16="http://schemas.microsoft.com/office/drawing/2014/main" id="{B6AE83BF-6330-575C-A41F-6FF2E0130CC2}"/>
+              </a:ext>
+            </a:extLst>
+          </p:cNvPr>
+          <p:cNvSpPr>
+            <a:spLocks noGrp="1"/>
+          </p:cNvSpPr>
+          <p:nvPr>
+            <p:ph type="title"/>
+          </p:nvPr>
+        </p:nvSpPr>
+        <p:spPr/>
+        <p:txBody>
+          <a:bodyPr>
+            <a:normAutofit fontScale="90000"/>
+          </a:bodyPr>
+          <a:lstStyle/>
+          <a:p>
+            <a:r>
+              <a:rPr lang="en-US" dirty="0"/>
+              <a:t>Some potential solutions</a:t>
+            </a:r>
+          </a:p>
+        </p:txBody>
+      </p:sp>
+      <p:sp>
+        <p:nvSpPr>
+          <p:cNvPr id="4" name="Google Shape;175;p27">
+            <a:extLst>
+              <a:ext uri="{FF2B5EF4-FFF2-40B4-BE49-F238E27FC236}">
+                <a16:creationId xmlns:a16="http://schemas.microsoft.com/office/drawing/2014/main" id="{B1D77E53-602A-DB57-E914-DCB5F0E69EFA}"/>
+              </a:ext>
+            </a:extLst>
+          </p:cNvPr>
+          <p:cNvSpPr txBox="1">
+            <a:spLocks noGrp="1"/>
+          </p:cNvSpPr>
+          <p:nvPr>
+            <p:ph type="body" idx="1"/>
+          </p:nvPr>
+        </p:nvSpPr>
+        <p:spPr>
+          <a:xfrm>
+            <a:off x="729450" y="2078875"/>
+            <a:ext cx="2635919" cy="1361909"/>
+          </a:xfrm>
+          <a:prstGeom prst="rect">
+            <a:avLst/>
+          </a:prstGeom>
+        </p:spPr>
+        <p:txBody>
+          <a:bodyPr spcFirstLastPara="1" wrap="square" lIns="91425" tIns="91425" rIns="91425" bIns="91425" anchor="t" anchorCtr="0">
+            <a:normAutofit/>
+          </a:bodyPr>
+          <a:lstStyle/>
+          <a:p>
+            <a:pPr marL="0" lvl="0" indent="0" algn="l" rtl="0">
+              <a:spcBef>
+                <a:spcPts val="0"/>
+              </a:spcBef>
+              <a:spcAft>
+                <a:spcPts val="0"/>
+              </a:spcAft>
+              <a:buNone/>
+            </a:pPr>
+            <a:r>
+              <a:rPr lang="en" sz="1600" i="1" dirty="0"/>
+              <a:t>S	=&gt;	S</a:t>
+            </a:r>
+            <a:r>
+              <a:rPr lang="en" sz="1600" dirty="0"/>
+              <a:t>a</a:t>
+            </a:r>
+            <a:r>
+              <a:rPr lang="en" sz="1600" i="1" dirty="0"/>
+              <a:t> </a:t>
+            </a:r>
+            <a:endParaRPr sz="1600" i="1" dirty="0"/>
+          </a:p>
+          <a:p>
+            <a:pPr marL="0" lvl="0" indent="0" algn="l" rtl="0">
+              <a:spcBef>
+                <a:spcPts val="1200"/>
+              </a:spcBef>
+              <a:spcAft>
+                <a:spcPts val="0"/>
+              </a:spcAft>
+              <a:buNone/>
+            </a:pPr>
+            <a:r>
+              <a:rPr lang="en" sz="1600" i="1" dirty="0"/>
+              <a:t>	</a:t>
+            </a:r>
+            <a:r>
+              <a:rPr lang="en" sz="1600" dirty="0"/>
+              <a:t>|	b</a:t>
+            </a:r>
+            <a:endParaRPr sz="1600" i="1" dirty="0"/>
+          </a:p>
+        </p:txBody>
+      </p:sp>
+      <p:sp>
+        <p:nvSpPr>
+          <p:cNvPr id="5" name="Google Shape;175;p27">
+            <a:extLst>
+              <a:ext uri="{FF2B5EF4-FFF2-40B4-BE49-F238E27FC236}">
+                <a16:creationId xmlns:a16="http://schemas.microsoft.com/office/drawing/2014/main" id="{D1FA4D3C-045D-67E0-DC81-2D35E8B3881F}"/>
+              </a:ext>
+            </a:extLst>
+          </p:cNvPr>
+          <p:cNvSpPr txBox="1">
+            <a:spLocks/>
+          </p:cNvSpPr>
+          <p:nvPr/>
+        </p:nvSpPr>
+        <p:spPr>
+          <a:xfrm>
+            <a:off x="4096391" y="2083853"/>
+            <a:ext cx="2635919" cy="1361909"/>
+          </a:xfrm>
+          <a:prstGeom prst="rect">
+            <a:avLst/>
+          </a:prstGeom>
+          <a:noFill/>
+          <a:ln>
+            <a:noFill/>
+          </a:ln>
+        </p:spPr>
+        <p:txBody>
+          <a:bodyPr spcFirstLastPara="1" wrap="square" lIns="91425" tIns="91425" rIns="91425" bIns="91425" anchor="t" anchorCtr="0">
+            <a:normAutofit/>
+          </a:bodyPr>
+          <a:lstStyle>
+            <a:defPPr marR="0" lvl="0" algn="l" rtl="0">
+              <a:lnSpc>
+                <a:spcPct val="100000"/>
+              </a:lnSpc>
+              <a:spcBef>
+                <a:spcPts val="0"/>
+              </a:spcBef>
+              <a:spcAft>
+                <a:spcPts val="0"/>
+              </a:spcAft>
+            </a:defPPr>
+            <a:lvl1pPr marL="457200" marR="0" lvl="0" indent="-311150" algn="l" rtl="0">
+              <a:lnSpc>
+                <a:spcPct val="115000"/>
+              </a:lnSpc>
+              <a:spcBef>
+                <a:spcPts val="0"/>
+              </a:spcBef>
+              <a:spcAft>
+                <a:spcPts val="0"/>
+              </a:spcAft>
+              <a:buClr>
+                <a:schemeClr val="accent1"/>
+              </a:buClr>
+              <a:buSzPts val="1300"/>
+              <a:buFont typeface="Lato"/>
+              <a:buChar char="●"/>
+              <a:defRPr sz="1300" b="0" i="0" u="none" strike="noStrike" cap="none">
+                <a:solidFill>
+                  <a:schemeClr val="accent1"/>
+                </a:solidFill>
+                <a:latin typeface="Lato"/>
+                <a:ea typeface="Lato"/>
+                <a:cs typeface="Lato"/>
+                <a:sym typeface="Lato"/>
+              </a:defRPr>
+            </a:lvl1pPr>
+            <a:lvl2pPr marL="914400" marR="0" lvl="1" indent="-298450" algn="l" rtl="0">
+              <a:lnSpc>
+                <a:spcPct val="115000"/>
+              </a:lnSpc>
+              <a:spcBef>
+                <a:spcPts val="0"/>
+              </a:spcBef>
+              <a:spcAft>
+                <a:spcPts val="0"/>
+              </a:spcAft>
+              <a:buClr>
+                <a:schemeClr val="accent1"/>
+              </a:buClr>
+              <a:buSzPts val="1100"/>
+              <a:buFont typeface="Lato"/>
+              <a:buChar char="○"/>
+              <a:defRPr sz="1100" b="0" i="0" u="none" strike="noStrike" cap="none">
+                <a:solidFill>
+                  <a:schemeClr val="accent1"/>
+                </a:solidFill>
+                <a:latin typeface="Lato"/>
+                <a:ea typeface="Lato"/>
+                <a:cs typeface="Lato"/>
+                <a:sym typeface="Lato"/>
+              </a:defRPr>
+            </a:lvl2pPr>
+            <a:lvl3pPr marL="1371600" marR="0" lvl="2" indent="-298450" algn="l" rtl="0">
+              <a:lnSpc>
+                <a:spcPct val="115000"/>
+              </a:lnSpc>
+              <a:spcBef>
+                <a:spcPts val="0"/>
+              </a:spcBef>
+              <a:spcAft>
+                <a:spcPts val="0"/>
+              </a:spcAft>
+              <a:buClr>
+                <a:schemeClr val="accent1"/>
+              </a:buClr>
+              <a:buSzPts val="1100"/>
+              <a:buFont typeface="Lato"/>
+              <a:buChar char="■"/>
+              <a:defRPr sz="1100" b="0" i="0" u="none" strike="noStrike" cap="none">
+                <a:solidFill>
+                  <a:schemeClr val="accent1"/>
+                </a:solidFill>
+                <a:latin typeface="Lato"/>
+                <a:ea typeface="Lato"/>
+                <a:cs typeface="Lato"/>
+                <a:sym typeface="Lato"/>
+              </a:defRPr>
+            </a:lvl3pPr>
+            <a:lvl4pPr marL="1828800" marR="0" lvl="3" indent="-298450" algn="l" rtl="0">
+              <a:lnSpc>
+                <a:spcPct val="115000"/>
+              </a:lnSpc>
+              <a:spcBef>
+                <a:spcPts val="0"/>
+              </a:spcBef>
+              <a:spcAft>
+                <a:spcPts val="0"/>
+              </a:spcAft>
+              <a:buClr>
+                <a:schemeClr val="accent1"/>
+              </a:buClr>
+              <a:buSzPts val="1100"/>
+              <a:buFont typeface="Lato"/>
+              <a:buChar char="●"/>
+              <a:defRPr sz="1100" b="0" i="0" u="none" strike="noStrike" cap="none">
+                <a:solidFill>
+                  <a:schemeClr val="accent1"/>
+                </a:solidFill>
+                <a:latin typeface="Lato"/>
+                <a:ea typeface="Lato"/>
+                <a:cs typeface="Lato"/>
+                <a:sym typeface="Lato"/>
+              </a:defRPr>
+            </a:lvl4pPr>
+            <a:lvl5pPr marL="2286000" marR="0" lvl="4" indent="-298450" algn="l" rtl="0">
+              <a:lnSpc>
+                <a:spcPct val="115000"/>
+              </a:lnSpc>
+              <a:spcBef>
+                <a:spcPts val="0"/>
+              </a:spcBef>
+              <a:spcAft>
+                <a:spcPts val="0"/>
+              </a:spcAft>
+              <a:buClr>
+                <a:schemeClr val="accent1"/>
+              </a:buClr>
+              <a:buSzPts val="1100"/>
+              <a:buFont typeface="Lato"/>
+              <a:buChar char="○"/>
+              <a:defRPr sz="1100" b="0" i="0" u="none" strike="noStrike" cap="none">
+                <a:solidFill>
+                  <a:schemeClr val="accent1"/>
+                </a:solidFill>
+                <a:latin typeface="Lato"/>
+                <a:ea typeface="Lato"/>
+                <a:cs typeface="Lato"/>
+                <a:sym typeface="Lato"/>
+              </a:defRPr>
+            </a:lvl5pPr>
+            <a:lvl6pPr marL="2743200" marR="0" lvl="5" indent="-298450" algn="l" rtl="0">
+              <a:lnSpc>
+                <a:spcPct val="115000"/>
+              </a:lnSpc>
+              <a:spcBef>
+                <a:spcPts val="0"/>
+              </a:spcBef>
+              <a:spcAft>
+                <a:spcPts val="0"/>
+              </a:spcAft>
+              <a:buClr>
+                <a:schemeClr val="accent1"/>
+              </a:buClr>
+              <a:buSzPts val="1100"/>
+              <a:buFont typeface="Lato"/>
+              <a:buChar char="■"/>
+              <a:defRPr sz="1100" b="0" i="0" u="none" strike="noStrike" cap="none">
+                <a:solidFill>
+                  <a:schemeClr val="accent1"/>
+                </a:solidFill>
+                <a:latin typeface="Lato"/>
+                <a:ea typeface="Lato"/>
+                <a:cs typeface="Lato"/>
+                <a:sym typeface="Lato"/>
+              </a:defRPr>
+            </a:lvl6pPr>
+            <a:lvl7pPr marL="3200400" marR="0" lvl="6" indent="-298450" algn="l" rtl="0">
+              <a:lnSpc>
+                <a:spcPct val="115000"/>
+              </a:lnSpc>
+              <a:spcBef>
+                <a:spcPts val="0"/>
+              </a:spcBef>
+              <a:spcAft>
+                <a:spcPts val="0"/>
+              </a:spcAft>
+              <a:buClr>
+                <a:schemeClr val="accent1"/>
+              </a:buClr>
+              <a:buSzPts val="1100"/>
+              <a:buFont typeface="Lato"/>
+              <a:buChar char="●"/>
+              <a:defRPr sz="1100" b="0" i="0" u="none" strike="noStrike" cap="none">
+                <a:solidFill>
+                  <a:schemeClr val="accent1"/>
+                </a:solidFill>
+                <a:latin typeface="Lato"/>
+                <a:ea typeface="Lato"/>
+                <a:cs typeface="Lato"/>
+                <a:sym typeface="Lato"/>
+              </a:defRPr>
+            </a:lvl7pPr>
+            <a:lvl8pPr marL="3657600" marR="0" lvl="7" indent="-298450" algn="l" rtl="0">
+              <a:lnSpc>
+                <a:spcPct val="115000"/>
+              </a:lnSpc>
+              <a:spcBef>
+                <a:spcPts val="0"/>
+              </a:spcBef>
+              <a:spcAft>
+                <a:spcPts val="0"/>
+              </a:spcAft>
+              <a:buClr>
+                <a:schemeClr val="accent1"/>
+              </a:buClr>
+              <a:buSzPts val="1100"/>
+              <a:buFont typeface="Lato"/>
+              <a:buChar char="○"/>
+              <a:defRPr sz="1100" b="0" i="0" u="none" strike="noStrike" cap="none">
+                <a:solidFill>
+                  <a:schemeClr val="accent1"/>
+                </a:solidFill>
+                <a:latin typeface="Lato"/>
+                <a:ea typeface="Lato"/>
+                <a:cs typeface="Lato"/>
+                <a:sym typeface="Lato"/>
+              </a:defRPr>
+            </a:lvl8pPr>
+            <a:lvl9pPr marL="4114800" marR="0" lvl="8" indent="-298450" algn="l" rtl="0">
+              <a:lnSpc>
+                <a:spcPct val="115000"/>
+              </a:lnSpc>
+              <a:spcBef>
+                <a:spcPts val="0"/>
+              </a:spcBef>
+              <a:spcAft>
+                <a:spcPts val="0"/>
+              </a:spcAft>
+              <a:buClr>
+                <a:schemeClr val="accent1"/>
+              </a:buClr>
+              <a:buSzPts val="1100"/>
+              <a:buFont typeface="Lato"/>
+              <a:buChar char="■"/>
+              <a:defRPr sz="1100" b="0" i="0" u="none" strike="noStrike" cap="none">
+                <a:solidFill>
+                  <a:schemeClr val="accent1"/>
+                </a:solidFill>
+                <a:latin typeface="Lato"/>
+                <a:ea typeface="Lato"/>
+                <a:cs typeface="Lato"/>
+                <a:sym typeface="Lato"/>
+              </a:defRPr>
+            </a:lvl9pPr>
+          </a:lstStyle>
+          <a:p>
+            <a:pPr marL="0" indent="0">
+              <a:buFont typeface="Lato"/>
+              <a:buNone/>
+            </a:pPr>
+            <a:r>
+              <a:rPr lang="en-US" sz="1600" i="1" dirty="0"/>
+              <a:t>S	=&gt;	</a:t>
+            </a:r>
+            <a:r>
+              <a:rPr lang="en-US" sz="1600" dirty="0" err="1"/>
+              <a:t>a</a:t>
+            </a:r>
+            <a:r>
+              <a:rPr lang="en-US" sz="1600" i="1" dirty="0" err="1"/>
+              <a:t>S</a:t>
+            </a:r>
+            <a:r>
+              <a:rPr lang="en-US" sz="1600" i="1" dirty="0"/>
+              <a:t> </a:t>
+            </a:r>
+          </a:p>
+          <a:p>
+            <a:pPr marL="0" indent="0">
+              <a:spcBef>
+                <a:spcPts val="1200"/>
+              </a:spcBef>
+              <a:buFont typeface="Lato"/>
+              <a:buNone/>
+            </a:pPr>
+            <a:r>
+              <a:rPr lang="en-US" sz="1600" i="1" dirty="0"/>
+              <a:t>	</a:t>
+            </a:r>
+            <a:r>
+              <a:rPr lang="en-US" sz="1600" dirty="0"/>
+              <a:t>|	b</a:t>
+            </a:r>
+            <a:endParaRPr lang="en-US" sz="1600" i="1" dirty="0"/>
+          </a:p>
+        </p:txBody>
+      </p:sp>
+    </p:spTree>
+    <p:extLst>
+      <p:ext uri="{BB962C8B-B14F-4D97-AF65-F5344CB8AC3E}">
+        <p14:creationId xmlns:p14="http://schemas.microsoft.com/office/powerpoint/2010/main" val="1299084200"/>
+      </p:ext>
+    </p:extLst>
+  </p:cSld>
+  <p:clrMapOvr>
+    <a:masterClrMapping/>
+  </p:clrMapOvr>
+</p:sld>
+</file>
+
+<file path=ppt/slides/slide19.xml><?xml version="1.0" encoding="utf-8"?>
 <p:sld xmlns:a="http://schemas.openxmlformats.org/drawingml/2006/main" xmlns:r="http://schemas.openxmlformats.org/officeDocument/2006/relationships" xmlns:p="http://schemas.openxmlformats.org/presentationml/2006/main">
   <p:cSld>
     <p:spTree>
@@ -11118,548 +12069,6 @@
             <a:r>
               <a:rPr lang="en" sz="1600"/>
               <a:t>This is the first thing we’ve run into that couldn’t be expressed via a regular language . . .</a:t>
-            </a:r>
-            <a:endParaRPr sz="1600"/>
-          </a:p>
-        </p:txBody>
-      </p:sp>
-    </p:spTree>
-  </p:cSld>
-  <p:clrMapOvr>
-    <a:masterClrMapping/>
-  </p:clrMapOvr>
-</p:sld>
-</file>
-
-<file path=ppt/slides/slide17.xml><?xml version="1.0" encoding="utf-8"?>
-<p:sld xmlns:a="http://schemas.openxmlformats.org/drawingml/2006/main" xmlns:r="http://schemas.openxmlformats.org/officeDocument/2006/relationships" xmlns:p="http://schemas.openxmlformats.org/presentationml/2006/main">
-  <p:cSld>
-    <p:spTree>
-      <p:nvGrpSpPr>
-        <p:cNvPr id="1" name="Shape 186"/>
-        <p:cNvGrpSpPr/>
-        <p:nvPr/>
-      </p:nvGrpSpPr>
-      <p:grpSpPr>
-        <a:xfrm>
-          <a:off x="0" y="0"/>
-          <a:ext cx="0" cy="0"/>
-          <a:chOff x="0" y="0"/>
-          <a:chExt cx="0" cy="0"/>
-        </a:xfrm>
-      </p:grpSpPr>
-      <p:sp>
-        <p:nvSpPr>
-          <p:cNvPr id="187" name="Google Shape;187;p29"/>
-          <p:cNvSpPr txBox="1">
-            <a:spLocks noGrp="1"/>
-          </p:cNvSpPr>
-          <p:nvPr>
-            <p:ph type="title"/>
-          </p:nvPr>
-        </p:nvSpPr>
-        <p:spPr>
-          <a:xfrm>
-            <a:off x="729450" y="1318650"/>
-            <a:ext cx="7688700" cy="535200"/>
-          </a:xfrm>
-          <a:prstGeom prst="rect">
-            <a:avLst/>
-          </a:prstGeom>
-        </p:spPr>
-        <p:txBody>
-          <a:bodyPr spcFirstLastPara="1" wrap="square" lIns="91425" tIns="91425" rIns="91425" bIns="91425" anchor="t" anchorCtr="0">
-            <a:normAutofit fontScale="90000"/>
-          </a:bodyPr>
-          <a:lstStyle/>
-          <a:p>
-            <a:pPr marL="0" lvl="0" indent="0" algn="l" rtl="0">
-              <a:spcBef>
-                <a:spcPts val="0"/>
-              </a:spcBef>
-              <a:spcAft>
-                <a:spcPts val="0"/>
-              </a:spcAft>
-              <a:buNone/>
-            </a:pPr>
-            <a:r>
-              <a:rPr lang="en"/>
-              <a:t>Solution</a:t>
-            </a:r>
-            <a:endParaRPr/>
-          </a:p>
-        </p:txBody>
-      </p:sp>
-      <p:sp>
-        <p:nvSpPr>
-          <p:cNvPr id="188" name="Google Shape;188;p29"/>
-          <p:cNvSpPr txBox="1">
-            <a:spLocks noGrp="1"/>
-          </p:cNvSpPr>
-          <p:nvPr>
-            <p:ph type="body" idx="1"/>
-          </p:nvPr>
-        </p:nvSpPr>
-        <p:spPr>
-          <a:xfrm>
-            <a:off x="729450" y="2078875"/>
-            <a:ext cx="7688700" cy="2261100"/>
-          </a:xfrm>
-          <a:prstGeom prst="rect">
-            <a:avLst/>
-          </a:prstGeom>
-        </p:spPr>
-        <p:txBody>
-          <a:bodyPr spcFirstLastPara="1" wrap="square" lIns="91425" tIns="91425" rIns="91425" bIns="91425" anchor="t" anchorCtr="0">
-            <a:normAutofit/>
-          </a:bodyPr>
-          <a:lstStyle/>
-          <a:p>
-            <a:pPr marL="0" lvl="0" indent="0" algn="l" rtl="0">
-              <a:spcBef>
-                <a:spcPts val="0"/>
-              </a:spcBef>
-              <a:spcAft>
-                <a:spcPts val="0"/>
-              </a:spcAft>
-              <a:buNone/>
-            </a:pPr>
-            <a:r>
-              <a:rPr lang="en" sz="1600" i="1"/>
-              <a:t>S</a:t>
-            </a:r>
-            <a:r>
-              <a:rPr lang="en" sz="1600"/>
-              <a:t> 	=&gt;	ab</a:t>
-            </a:r>
-            <a:endParaRPr sz="1600"/>
-          </a:p>
-          <a:p>
-            <a:pPr marL="0" lvl="0" indent="0" algn="l" rtl="0">
-              <a:spcBef>
-                <a:spcPts val="1200"/>
-              </a:spcBef>
-              <a:spcAft>
-                <a:spcPts val="1200"/>
-              </a:spcAft>
-              <a:buNone/>
-            </a:pPr>
-            <a:r>
-              <a:rPr lang="en" sz="1600"/>
-              <a:t>	|	a</a:t>
-            </a:r>
-            <a:r>
-              <a:rPr lang="en" sz="1600" i="1"/>
-              <a:t>S</a:t>
-            </a:r>
-            <a:r>
-              <a:rPr lang="en" sz="1600"/>
-              <a:t>b</a:t>
-            </a:r>
-            <a:endParaRPr sz="1600"/>
-          </a:p>
-        </p:txBody>
-      </p:sp>
-    </p:spTree>
-  </p:cSld>
-  <p:clrMapOvr>
-    <a:masterClrMapping/>
-  </p:clrMapOvr>
-</p:sld>
-</file>
-
-<file path=ppt/slides/slide18.xml><?xml version="1.0" encoding="utf-8"?>
-<p:sld xmlns:a="http://schemas.openxmlformats.org/drawingml/2006/main" xmlns:r="http://schemas.openxmlformats.org/officeDocument/2006/relationships" xmlns:p="http://schemas.openxmlformats.org/presentationml/2006/main">
-  <p:cSld>
-    <p:spTree>
-      <p:nvGrpSpPr>
-        <p:cNvPr id="1" name="Shape 192"/>
-        <p:cNvGrpSpPr/>
-        <p:nvPr/>
-      </p:nvGrpSpPr>
-      <p:grpSpPr>
-        <a:xfrm>
-          <a:off x="0" y="0"/>
-          <a:ext cx="0" cy="0"/>
-          <a:chOff x="0" y="0"/>
-          <a:chExt cx="0" cy="0"/>
-        </a:xfrm>
-      </p:grpSpPr>
-      <p:sp>
-        <p:nvSpPr>
-          <p:cNvPr id="193" name="Google Shape;193;p30"/>
-          <p:cNvSpPr txBox="1">
-            <a:spLocks noGrp="1"/>
-          </p:cNvSpPr>
-          <p:nvPr>
-            <p:ph type="title"/>
-          </p:nvPr>
-        </p:nvSpPr>
-        <p:spPr>
-          <a:xfrm>
-            <a:off x="729450" y="1318650"/>
-            <a:ext cx="7688700" cy="535200"/>
-          </a:xfrm>
-          <a:prstGeom prst="rect">
-            <a:avLst/>
-          </a:prstGeom>
-        </p:spPr>
-        <p:txBody>
-          <a:bodyPr spcFirstLastPara="1" wrap="square" lIns="91425" tIns="91425" rIns="91425" bIns="91425" anchor="t" anchorCtr="0">
-            <a:normAutofit fontScale="90000"/>
-          </a:bodyPr>
-          <a:lstStyle/>
-          <a:p>
-            <a:pPr marL="0" lvl="0" indent="0" algn="l" rtl="0">
-              <a:spcBef>
-                <a:spcPts val="0"/>
-              </a:spcBef>
-              <a:spcAft>
-                <a:spcPts val="0"/>
-              </a:spcAft>
-              <a:buNone/>
-            </a:pPr>
-            <a:r>
-              <a:rPr lang="en"/>
-              <a:t>Yet another example</a:t>
-            </a:r>
-            <a:endParaRPr/>
-          </a:p>
-        </p:txBody>
-      </p:sp>
-      <p:sp>
-        <p:nvSpPr>
-          <p:cNvPr id="194" name="Google Shape;194;p30"/>
-          <p:cNvSpPr txBox="1">
-            <a:spLocks noGrp="1"/>
-          </p:cNvSpPr>
-          <p:nvPr>
-            <p:ph type="body" idx="1"/>
-          </p:nvPr>
-        </p:nvSpPr>
-        <p:spPr>
-          <a:xfrm>
-            <a:off x="729450" y="2078875"/>
-            <a:ext cx="7688700" cy="2261100"/>
-          </a:xfrm>
-          <a:prstGeom prst="rect">
-            <a:avLst/>
-          </a:prstGeom>
-        </p:spPr>
-        <p:txBody>
-          <a:bodyPr spcFirstLastPara="1" wrap="square" lIns="91425" tIns="91425" rIns="91425" bIns="91425" anchor="t" anchorCtr="0">
-            <a:normAutofit/>
-          </a:bodyPr>
-          <a:lstStyle/>
-          <a:p>
-            <a:pPr marL="0" lvl="0" indent="0" algn="l" rtl="0">
-              <a:spcBef>
-                <a:spcPts val="0"/>
-              </a:spcBef>
-              <a:spcAft>
-                <a:spcPts val="0"/>
-              </a:spcAft>
-              <a:buNone/>
-            </a:pPr>
-            <a:r>
-              <a:rPr lang="en" sz="1600"/>
-              <a:t>The language of 3 b’s, followed by 1 or many c’s, followed by 0 or many d’s</a:t>
-            </a:r>
-            <a:endParaRPr sz="1600"/>
-          </a:p>
-          <a:p>
-            <a:pPr marL="457200" lvl="0" indent="-330200" algn="l" rtl="0">
-              <a:spcBef>
-                <a:spcPts val="1200"/>
-              </a:spcBef>
-              <a:spcAft>
-                <a:spcPts val="0"/>
-              </a:spcAft>
-              <a:buSzPts val="1600"/>
-              <a:buChar char="-"/>
-            </a:pPr>
-            <a:r>
-              <a:rPr lang="en" sz="1600"/>
-              <a:t>{bbbc</a:t>
-            </a:r>
-            <a:r>
-              <a:rPr lang="en" sz="1600" baseline="30000"/>
-              <a:t>n</a:t>
-            </a:r>
-            <a:r>
-              <a:rPr lang="en" sz="1600"/>
-              <a:t>d</a:t>
-            </a:r>
-            <a:r>
-              <a:rPr lang="en" sz="1600" baseline="30000"/>
-              <a:t>m</a:t>
-            </a:r>
-            <a:r>
-              <a:rPr lang="en" sz="1600"/>
-              <a:t>|n ∈ N, m ∈ N, n &gt; 0, m &gt;= 0} </a:t>
-            </a:r>
-            <a:endParaRPr sz="1600"/>
-          </a:p>
-          <a:p>
-            <a:pPr marL="457200" lvl="0" indent="-330200" algn="l" rtl="0">
-              <a:spcBef>
-                <a:spcPts val="0"/>
-              </a:spcBef>
-              <a:spcAft>
-                <a:spcPts val="0"/>
-              </a:spcAft>
-              <a:buSzPts val="1600"/>
-              <a:buChar char="-"/>
-            </a:pPr>
-            <a:r>
-              <a:rPr lang="en" sz="1600"/>
-              <a:t>Can we express this in a regular language?</a:t>
-            </a:r>
-            <a:endParaRPr sz="1600"/>
-          </a:p>
-          <a:p>
-            <a:pPr marL="457200" lvl="0" indent="-330200" algn="l" rtl="0">
-              <a:spcBef>
-                <a:spcPts val="0"/>
-              </a:spcBef>
-              <a:spcAft>
-                <a:spcPts val="0"/>
-              </a:spcAft>
-              <a:buSzPts val="1600"/>
-              <a:buChar char="-"/>
-            </a:pPr>
-            <a:r>
-              <a:rPr lang="en" sz="1600"/>
-              <a:t>What does the BNF for this look like?</a:t>
-            </a:r>
-            <a:endParaRPr sz="1600"/>
-          </a:p>
-          <a:p>
-            <a:pPr marL="0" lvl="0" indent="0" algn="l" rtl="0">
-              <a:spcBef>
-                <a:spcPts val="1200"/>
-              </a:spcBef>
-              <a:spcAft>
-                <a:spcPts val="1200"/>
-              </a:spcAft>
-              <a:buNone/>
-            </a:pPr>
-            <a:endParaRPr sz="1600"/>
-          </a:p>
-        </p:txBody>
-      </p:sp>
-    </p:spTree>
-  </p:cSld>
-  <p:clrMapOvr>
-    <a:masterClrMapping/>
-  </p:clrMapOvr>
-</p:sld>
-</file>
-
-<file path=ppt/slides/slide19.xml><?xml version="1.0" encoding="utf-8"?>
-<p:sld xmlns:a="http://schemas.openxmlformats.org/drawingml/2006/main" xmlns:r="http://schemas.openxmlformats.org/officeDocument/2006/relationships" xmlns:p="http://schemas.openxmlformats.org/presentationml/2006/main">
-  <p:cSld>
-    <p:spTree>
-      <p:nvGrpSpPr>
-        <p:cNvPr id="1" name="Shape 198"/>
-        <p:cNvGrpSpPr/>
-        <p:nvPr/>
-      </p:nvGrpSpPr>
-      <p:grpSpPr>
-        <a:xfrm>
-          <a:off x="0" y="0"/>
-          <a:ext cx="0" cy="0"/>
-          <a:chOff x="0" y="0"/>
-          <a:chExt cx="0" cy="0"/>
-        </a:xfrm>
-      </p:grpSpPr>
-      <p:sp>
-        <p:nvSpPr>
-          <p:cNvPr id="199" name="Google Shape;199;p31"/>
-          <p:cNvSpPr txBox="1">
-            <a:spLocks noGrp="1"/>
-          </p:cNvSpPr>
-          <p:nvPr>
-            <p:ph type="title"/>
-          </p:nvPr>
-        </p:nvSpPr>
-        <p:spPr>
-          <a:xfrm>
-            <a:off x="729450" y="1318650"/>
-            <a:ext cx="7688700" cy="535200"/>
-          </a:xfrm>
-          <a:prstGeom prst="rect">
-            <a:avLst/>
-          </a:prstGeom>
-        </p:spPr>
-        <p:txBody>
-          <a:bodyPr spcFirstLastPara="1" wrap="square" lIns="91425" tIns="91425" rIns="91425" bIns="91425" anchor="t" anchorCtr="0">
-            <a:normAutofit fontScale="90000"/>
-          </a:bodyPr>
-          <a:lstStyle/>
-          <a:p>
-            <a:pPr marL="0" lvl="0" indent="0" algn="l" rtl="0">
-              <a:spcBef>
-                <a:spcPts val="0"/>
-              </a:spcBef>
-              <a:spcAft>
-                <a:spcPts val="0"/>
-              </a:spcAft>
-              <a:buNone/>
-            </a:pPr>
-            <a:r>
-              <a:rPr lang="en"/>
-              <a:t>Solution</a:t>
-            </a:r>
-            <a:endParaRPr/>
-          </a:p>
-        </p:txBody>
-      </p:sp>
-      <p:sp>
-        <p:nvSpPr>
-          <p:cNvPr id="200" name="Google Shape;200;p31"/>
-          <p:cNvSpPr txBox="1">
-            <a:spLocks noGrp="1"/>
-          </p:cNvSpPr>
-          <p:nvPr>
-            <p:ph type="body" idx="1"/>
-          </p:nvPr>
-        </p:nvSpPr>
-        <p:spPr>
-          <a:xfrm>
-            <a:off x="729450" y="1853850"/>
-            <a:ext cx="7688700" cy="2856900"/>
-          </a:xfrm>
-          <a:prstGeom prst="rect">
-            <a:avLst/>
-          </a:prstGeom>
-        </p:spPr>
-        <p:txBody>
-          <a:bodyPr spcFirstLastPara="1" wrap="square" lIns="91425" tIns="91425" rIns="91425" bIns="91425" anchor="t" anchorCtr="0">
-            <a:normAutofit/>
-          </a:bodyPr>
-          <a:lstStyle/>
-          <a:p>
-            <a:pPr marL="0" lvl="0" indent="0" algn="l" rtl="0">
-              <a:spcBef>
-                <a:spcPts val="0"/>
-              </a:spcBef>
-              <a:spcAft>
-                <a:spcPts val="0"/>
-              </a:spcAft>
-              <a:buNone/>
-            </a:pPr>
-            <a:r>
-              <a:rPr lang="en" sz="1600"/>
-              <a:t>There are a couple of potential solutions; this is mine:</a:t>
-            </a:r>
-            <a:endParaRPr sz="1600"/>
-          </a:p>
-          <a:p>
-            <a:pPr marL="0" lvl="0" indent="0" algn="l" rtl="0">
-              <a:spcBef>
-                <a:spcPts val="1200"/>
-              </a:spcBef>
-              <a:spcAft>
-                <a:spcPts val="0"/>
-              </a:spcAft>
-              <a:buNone/>
-            </a:pPr>
-            <a:r>
-              <a:rPr lang="en" sz="1600" i="1"/>
-              <a:t>S 	=&gt;	</a:t>
-            </a:r>
-            <a:r>
-              <a:rPr lang="en" sz="1600"/>
-              <a:t>bbb</a:t>
-            </a:r>
-            <a:r>
-              <a:rPr lang="en" sz="1600" i="1"/>
-              <a:t>QR</a:t>
-            </a:r>
-            <a:endParaRPr sz="1600" i="1"/>
-          </a:p>
-          <a:p>
-            <a:pPr marL="0" lvl="0" indent="0" algn="l" rtl="0">
-              <a:spcBef>
-                <a:spcPts val="1200"/>
-              </a:spcBef>
-              <a:spcAft>
-                <a:spcPts val="0"/>
-              </a:spcAft>
-              <a:buNone/>
-            </a:pPr>
-            <a:r>
-              <a:rPr lang="en" sz="1600" i="1"/>
-              <a:t>Q	=&gt;	</a:t>
-            </a:r>
-            <a:r>
-              <a:rPr lang="en" sz="1600"/>
-              <a:t>c</a:t>
-            </a:r>
-            <a:r>
-              <a:rPr lang="en" sz="1600" i="1"/>
-              <a:t>Q</a:t>
-            </a:r>
-            <a:endParaRPr sz="1600"/>
-          </a:p>
-          <a:p>
-            <a:pPr marL="0" lvl="0" indent="0" algn="l" rtl="0">
-              <a:spcBef>
-                <a:spcPts val="1200"/>
-              </a:spcBef>
-              <a:spcAft>
-                <a:spcPts val="0"/>
-              </a:spcAft>
-              <a:buNone/>
-            </a:pPr>
-            <a:r>
-              <a:rPr lang="en" sz="1600"/>
-              <a:t>	|	c</a:t>
-            </a:r>
-            <a:endParaRPr sz="1600"/>
-          </a:p>
-          <a:p>
-            <a:pPr marL="0" lvl="0" indent="0" algn="l" rtl="0">
-              <a:spcBef>
-                <a:spcPts val="1200"/>
-              </a:spcBef>
-              <a:spcAft>
-                <a:spcPts val="0"/>
-              </a:spcAft>
-              <a:buNone/>
-            </a:pPr>
-            <a:r>
-              <a:rPr lang="en" sz="1600" i="1"/>
-              <a:t>R</a:t>
-            </a:r>
-            <a:r>
-              <a:rPr lang="en" sz="1600"/>
-              <a:t>	=&gt;	d</a:t>
-            </a:r>
-            <a:r>
-              <a:rPr lang="en" sz="1600" i="1"/>
-              <a:t>R</a:t>
-            </a:r>
-            <a:endParaRPr sz="1600" i="1"/>
-          </a:p>
-          <a:p>
-            <a:pPr marL="0" lvl="0" indent="0" algn="l" rtl="0">
-              <a:spcBef>
-                <a:spcPts val="1200"/>
-              </a:spcBef>
-              <a:spcAft>
-                <a:spcPts val="1200"/>
-              </a:spcAft>
-              <a:buNone/>
-            </a:pPr>
-            <a:r>
-              <a:rPr lang="en" sz="1600" i="1"/>
-              <a:t>	</a:t>
-            </a:r>
-            <a:r>
-              <a:rPr lang="en" sz="1600"/>
-              <a:t>|	ε</a:t>
             </a:r>
             <a:endParaRPr sz="1600"/>
           </a:p>
@@ -11772,7 +12181,7 @@
               <a:buChar char="-"/>
             </a:pPr>
             <a:r>
-              <a:rPr lang="en" sz="1650">
+              <a:rPr lang="en" sz="1650" dirty="0">
                 <a:solidFill>
                   <a:srgbClr val="000000"/>
                 </a:solidFill>
@@ -11787,7 +12196,7 @@
               <a:t>In this course we will build our own language called </a:t>
             </a:r>
             <a:r>
-              <a:rPr lang="en" sz="1650">
+              <a:rPr lang="en" sz="1650" dirty="0">
                 <a:solidFill>
                   <a:srgbClr val="188038"/>
                 </a:solidFill>
@@ -11802,7 +12211,7 @@
               <a:t>Lettuce</a:t>
             </a:r>
             <a:r>
-              <a:rPr lang="en" sz="1650">
+              <a:rPr lang="en" sz="1650" dirty="0">
                 <a:solidFill>
                   <a:srgbClr val="000000"/>
                 </a:solidFill>
@@ -11814,9 +12223,39 @@
                 <a:cs typeface="Arial"/>
                 <a:sym typeface="Arial"/>
               </a:rPr>
-              <a:t> (inspired by OCaml)</a:t>
-            </a:r>
-            <a:endParaRPr sz="1650">
+              <a:t> (inspired by </a:t>
+            </a:r>
+            <a:r>
+              <a:rPr lang="en" sz="1650" dirty="0" err="1">
+                <a:solidFill>
+                  <a:srgbClr val="000000"/>
+                </a:solidFill>
+                <a:highlight>
+                  <a:srgbClr val="FFFFFF"/>
+                </a:highlight>
+                <a:latin typeface="Arial"/>
+                <a:ea typeface="Arial"/>
+                <a:cs typeface="Arial"/>
+                <a:sym typeface="Arial"/>
+              </a:rPr>
+              <a:t>OCaml</a:t>
+            </a:r>
+            <a:r>
+              <a:rPr lang="en" sz="1650" dirty="0">
+                <a:solidFill>
+                  <a:srgbClr val="000000"/>
+                </a:solidFill>
+                <a:highlight>
+                  <a:srgbClr val="FFFFFF"/>
+                </a:highlight>
+                <a:latin typeface="Arial"/>
+                <a:ea typeface="Arial"/>
+                <a:cs typeface="Arial"/>
+                <a:sym typeface="Arial"/>
+              </a:rPr>
+              <a:t>)</a:t>
+            </a:r>
+            <a:endParaRPr sz="1650" dirty="0">
               <a:solidFill>
                 <a:srgbClr val="000000"/>
               </a:solidFill>
@@ -11845,7 +12284,7 @@
               <a:buChar char="-"/>
             </a:pPr>
             <a:r>
-              <a:rPr lang="en" sz="1650">
+              <a:rPr lang="en" sz="1650" dirty="0">
                 <a:solidFill>
                   <a:srgbClr val="000000"/>
                 </a:solidFill>
@@ -11859,7 +12298,7 @@
               </a:rPr>
               <a:t>And an interpreter for that language</a:t>
             </a:r>
-            <a:endParaRPr sz="1650">
+            <a:endParaRPr sz="1650" dirty="0">
               <a:solidFill>
                 <a:srgbClr val="000000"/>
               </a:solidFill>
@@ -11888,7 +12327,7 @@
               <a:buChar char="-"/>
             </a:pPr>
             <a:r>
-              <a:rPr lang="en" sz="1650">
+              <a:rPr lang="en" sz="1650" dirty="0">
                 <a:solidFill>
                   <a:srgbClr val="000000"/>
                 </a:solidFill>
@@ -11900,9 +12339,69 @@
                 <a:cs typeface="Arial"/>
                 <a:sym typeface="Arial"/>
               </a:rPr>
-              <a:t>We will use backus naur form (BNF) grammars</a:t>
-            </a:r>
-            <a:endParaRPr sz="1650">
+              <a:t>We will use </a:t>
+            </a:r>
+            <a:r>
+              <a:rPr lang="en" sz="1650" dirty="0" err="1">
+                <a:solidFill>
+                  <a:srgbClr val="000000"/>
+                </a:solidFill>
+                <a:highlight>
+                  <a:srgbClr val="FFFFFF"/>
+                </a:highlight>
+                <a:latin typeface="Arial"/>
+                <a:ea typeface="Arial"/>
+                <a:cs typeface="Arial"/>
+                <a:sym typeface="Arial"/>
+              </a:rPr>
+              <a:t>backus</a:t>
+            </a:r>
+            <a:r>
+              <a:rPr lang="en" sz="1650" dirty="0">
+                <a:solidFill>
+                  <a:srgbClr val="000000"/>
+                </a:solidFill>
+                <a:highlight>
+                  <a:srgbClr val="FFFFFF"/>
+                </a:highlight>
+                <a:latin typeface="Arial"/>
+                <a:ea typeface="Arial"/>
+                <a:cs typeface="Arial"/>
+                <a:sym typeface="Arial"/>
+              </a:rPr>
+              <a:t> </a:t>
+            </a:r>
+            <a:r>
+              <a:rPr lang="en" sz="1650" dirty="0" err="1">
+                <a:solidFill>
+                  <a:srgbClr val="000000"/>
+                </a:solidFill>
+                <a:highlight>
+                  <a:srgbClr val="FFFFFF"/>
+                </a:highlight>
+                <a:latin typeface="Arial"/>
+                <a:ea typeface="Arial"/>
+                <a:cs typeface="Arial"/>
+                <a:sym typeface="Arial"/>
+              </a:rPr>
+              <a:t>naur</a:t>
+            </a:r>
+            <a:r>
+              <a:rPr lang="en" sz="1650" dirty="0">
+                <a:solidFill>
+                  <a:srgbClr val="000000"/>
+                </a:solidFill>
+                <a:highlight>
+                  <a:srgbClr val="FFFFFF"/>
+                </a:highlight>
+                <a:latin typeface="Arial"/>
+                <a:ea typeface="Arial"/>
+                <a:cs typeface="Arial"/>
+                <a:sym typeface="Arial"/>
+              </a:rPr>
+              <a:t> form (BNF) grammars</a:t>
+            </a:r>
+            <a:endParaRPr sz="1650" dirty="0">
               <a:solidFill>
                 <a:srgbClr val="000000"/>
               </a:solidFill>
@@ -11931,7 +12430,7 @@
               <a:buChar char="-"/>
             </a:pPr>
             <a:r>
-              <a:rPr lang="en" sz="1650">
+              <a:rPr lang="en" sz="1650" dirty="0">
                 <a:solidFill>
                   <a:srgbClr val="000000"/>
                 </a:solidFill>
@@ -11945,7 +12444,7 @@
               </a:rPr>
               <a:t>Once we’ve got our grammar, we can define semantic rules (inference rules) over possible patterns that arise</a:t>
             </a:r>
-            <a:endParaRPr sz="1650">
+            <a:endParaRPr sz="1650" dirty="0">
               <a:solidFill>
                 <a:srgbClr val="000000"/>
               </a:solidFill>
@@ -11969,6 +12468,548 @@
 </file>
 
 <file path=ppt/slides/slide20.xml><?xml version="1.0" encoding="utf-8"?>
+<p:sld xmlns:a="http://schemas.openxmlformats.org/drawingml/2006/main" xmlns:r="http://schemas.openxmlformats.org/officeDocument/2006/relationships" xmlns:p="http://schemas.openxmlformats.org/presentationml/2006/main">
+  <p:cSld>
+    <p:spTree>
+      <p:nvGrpSpPr>
+        <p:cNvPr id="1" name="Shape 186"/>
+        <p:cNvGrpSpPr/>
+        <p:nvPr/>
+      </p:nvGrpSpPr>
+      <p:grpSpPr>
+        <a:xfrm>
+          <a:off x="0" y="0"/>
+          <a:ext cx="0" cy="0"/>
+          <a:chOff x="0" y="0"/>
+          <a:chExt cx="0" cy="0"/>
+        </a:xfrm>
+      </p:grpSpPr>
+      <p:sp>
+        <p:nvSpPr>
+          <p:cNvPr id="187" name="Google Shape;187;p29"/>
+          <p:cNvSpPr txBox="1">
+            <a:spLocks noGrp="1"/>
+          </p:cNvSpPr>
+          <p:nvPr>
+            <p:ph type="title"/>
+          </p:nvPr>
+        </p:nvSpPr>
+        <p:spPr>
+          <a:xfrm>
+            <a:off x="729450" y="1318650"/>
+            <a:ext cx="7688700" cy="535200"/>
+          </a:xfrm>
+          <a:prstGeom prst="rect">
+            <a:avLst/>
+          </a:prstGeom>
+        </p:spPr>
+        <p:txBody>
+          <a:bodyPr spcFirstLastPara="1" wrap="square" lIns="91425" tIns="91425" rIns="91425" bIns="91425" anchor="t" anchorCtr="0">
+            <a:normAutofit fontScale="90000"/>
+          </a:bodyPr>
+          <a:lstStyle/>
+          <a:p>
+            <a:pPr marL="0" lvl="0" indent="0" algn="l" rtl="0">
+              <a:spcBef>
+                <a:spcPts val="0"/>
+              </a:spcBef>
+              <a:spcAft>
+                <a:spcPts val="0"/>
+              </a:spcAft>
+              <a:buNone/>
+            </a:pPr>
+            <a:r>
+              <a:rPr lang="en"/>
+              <a:t>Solution</a:t>
+            </a:r>
+            <a:endParaRPr/>
+          </a:p>
+        </p:txBody>
+      </p:sp>
+      <p:sp>
+        <p:nvSpPr>
+          <p:cNvPr id="188" name="Google Shape;188;p29"/>
+          <p:cNvSpPr txBox="1">
+            <a:spLocks noGrp="1"/>
+          </p:cNvSpPr>
+          <p:nvPr>
+            <p:ph type="body" idx="1"/>
+          </p:nvPr>
+        </p:nvSpPr>
+        <p:spPr>
+          <a:xfrm>
+            <a:off x="729450" y="2078875"/>
+            <a:ext cx="7688700" cy="2261100"/>
+          </a:xfrm>
+          <a:prstGeom prst="rect">
+            <a:avLst/>
+          </a:prstGeom>
+        </p:spPr>
+        <p:txBody>
+          <a:bodyPr spcFirstLastPara="1" wrap="square" lIns="91425" tIns="91425" rIns="91425" bIns="91425" anchor="t" anchorCtr="0">
+            <a:normAutofit/>
+          </a:bodyPr>
+          <a:lstStyle/>
+          <a:p>
+            <a:pPr marL="0" lvl="0" indent="0" algn="l" rtl="0">
+              <a:spcBef>
+                <a:spcPts val="0"/>
+              </a:spcBef>
+              <a:spcAft>
+                <a:spcPts val="0"/>
+              </a:spcAft>
+              <a:buNone/>
+            </a:pPr>
+            <a:r>
+              <a:rPr lang="en" sz="1600" i="1"/>
+              <a:t>S</a:t>
+            </a:r>
+            <a:r>
+              <a:rPr lang="en" sz="1600"/>
+              <a:t> 	=&gt;	ab</a:t>
+            </a:r>
+            <a:endParaRPr sz="1600"/>
+          </a:p>
+          <a:p>
+            <a:pPr marL="0" lvl="0" indent="0" algn="l" rtl="0">
+              <a:spcBef>
+                <a:spcPts val="1200"/>
+              </a:spcBef>
+              <a:spcAft>
+                <a:spcPts val="1200"/>
+              </a:spcAft>
+              <a:buNone/>
+            </a:pPr>
+            <a:r>
+              <a:rPr lang="en" sz="1600"/>
+              <a:t>	|	a</a:t>
+            </a:r>
+            <a:r>
+              <a:rPr lang="en" sz="1600" i="1"/>
+              <a:t>S</a:t>
+            </a:r>
+            <a:r>
+              <a:rPr lang="en" sz="1600"/>
+              <a:t>b</a:t>
+            </a:r>
+            <a:endParaRPr sz="1600"/>
+          </a:p>
+        </p:txBody>
+      </p:sp>
+    </p:spTree>
+  </p:cSld>
+  <p:clrMapOvr>
+    <a:masterClrMapping/>
+  </p:clrMapOvr>
+</p:sld>
+</file>
+
+<file path=ppt/slides/slide21.xml><?xml version="1.0" encoding="utf-8"?>
+<p:sld xmlns:a="http://schemas.openxmlformats.org/drawingml/2006/main" xmlns:r="http://schemas.openxmlformats.org/officeDocument/2006/relationships" xmlns:p="http://schemas.openxmlformats.org/presentationml/2006/main">
+  <p:cSld>
+    <p:spTree>
+      <p:nvGrpSpPr>
+        <p:cNvPr id="1" name="Shape 192"/>
+        <p:cNvGrpSpPr/>
+        <p:nvPr/>
+      </p:nvGrpSpPr>
+      <p:grpSpPr>
+        <a:xfrm>
+          <a:off x="0" y="0"/>
+          <a:ext cx="0" cy="0"/>
+          <a:chOff x="0" y="0"/>
+          <a:chExt cx="0" cy="0"/>
+        </a:xfrm>
+      </p:grpSpPr>
+      <p:sp>
+        <p:nvSpPr>
+          <p:cNvPr id="193" name="Google Shape;193;p30"/>
+          <p:cNvSpPr txBox="1">
+            <a:spLocks noGrp="1"/>
+          </p:cNvSpPr>
+          <p:nvPr>
+            <p:ph type="title"/>
+          </p:nvPr>
+        </p:nvSpPr>
+        <p:spPr>
+          <a:xfrm>
+            <a:off x="729450" y="1318650"/>
+            <a:ext cx="7688700" cy="535200"/>
+          </a:xfrm>
+          <a:prstGeom prst="rect">
+            <a:avLst/>
+          </a:prstGeom>
+        </p:spPr>
+        <p:txBody>
+          <a:bodyPr spcFirstLastPara="1" wrap="square" lIns="91425" tIns="91425" rIns="91425" bIns="91425" anchor="t" anchorCtr="0">
+            <a:normAutofit fontScale="90000"/>
+          </a:bodyPr>
+          <a:lstStyle/>
+          <a:p>
+            <a:pPr marL="0" lvl="0" indent="0" algn="l" rtl="0">
+              <a:spcBef>
+                <a:spcPts val="0"/>
+              </a:spcBef>
+              <a:spcAft>
+                <a:spcPts val="0"/>
+              </a:spcAft>
+              <a:buNone/>
+            </a:pPr>
+            <a:r>
+              <a:rPr lang="en"/>
+              <a:t>Yet another example</a:t>
+            </a:r>
+            <a:endParaRPr/>
+          </a:p>
+        </p:txBody>
+      </p:sp>
+      <p:sp>
+        <p:nvSpPr>
+          <p:cNvPr id="194" name="Google Shape;194;p30"/>
+          <p:cNvSpPr txBox="1">
+            <a:spLocks noGrp="1"/>
+          </p:cNvSpPr>
+          <p:nvPr>
+            <p:ph type="body" idx="1"/>
+          </p:nvPr>
+        </p:nvSpPr>
+        <p:spPr>
+          <a:xfrm>
+            <a:off x="729450" y="2078875"/>
+            <a:ext cx="7688700" cy="2261100"/>
+          </a:xfrm>
+          <a:prstGeom prst="rect">
+            <a:avLst/>
+          </a:prstGeom>
+        </p:spPr>
+        <p:txBody>
+          <a:bodyPr spcFirstLastPara="1" wrap="square" lIns="91425" tIns="91425" rIns="91425" bIns="91425" anchor="t" anchorCtr="0">
+            <a:normAutofit/>
+          </a:bodyPr>
+          <a:lstStyle/>
+          <a:p>
+            <a:pPr marL="0" lvl="0" indent="0" algn="l" rtl="0">
+              <a:spcBef>
+                <a:spcPts val="0"/>
+              </a:spcBef>
+              <a:spcAft>
+                <a:spcPts val="0"/>
+              </a:spcAft>
+              <a:buNone/>
+            </a:pPr>
+            <a:r>
+              <a:rPr lang="en" sz="1600"/>
+              <a:t>The language of 3 b’s, followed by 1 or many c’s, followed by 0 or many d’s</a:t>
+            </a:r>
+            <a:endParaRPr sz="1600"/>
+          </a:p>
+          <a:p>
+            <a:pPr marL="457200" lvl="0" indent="-330200" algn="l" rtl="0">
+              <a:spcBef>
+                <a:spcPts val="1200"/>
+              </a:spcBef>
+              <a:spcAft>
+                <a:spcPts val="0"/>
+              </a:spcAft>
+              <a:buSzPts val="1600"/>
+              <a:buChar char="-"/>
+            </a:pPr>
+            <a:r>
+              <a:rPr lang="en" sz="1600"/>
+              <a:t>{bbbc</a:t>
+            </a:r>
+            <a:r>
+              <a:rPr lang="en" sz="1600" baseline="30000"/>
+              <a:t>n</a:t>
+            </a:r>
+            <a:r>
+              <a:rPr lang="en" sz="1600"/>
+              <a:t>d</a:t>
+            </a:r>
+            <a:r>
+              <a:rPr lang="en" sz="1600" baseline="30000"/>
+              <a:t>m</a:t>
+            </a:r>
+            <a:r>
+              <a:rPr lang="en" sz="1600"/>
+              <a:t>|n ∈ N, m ∈ N, n &gt; 0, m &gt;= 0} </a:t>
+            </a:r>
+            <a:endParaRPr sz="1600"/>
+          </a:p>
+          <a:p>
+            <a:pPr marL="457200" lvl="0" indent="-330200" algn="l" rtl="0">
+              <a:spcBef>
+                <a:spcPts val="0"/>
+              </a:spcBef>
+              <a:spcAft>
+                <a:spcPts val="0"/>
+              </a:spcAft>
+              <a:buSzPts val="1600"/>
+              <a:buChar char="-"/>
+            </a:pPr>
+            <a:r>
+              <a:rPr lang="en" sz="1600"/>
+              <a:t>Can we express this in a regular language?</a:t>
+            </a:r>
+            <a:endParaRPr sz="1600"/>
+          </a:p>
+          <a:p>
+            <a:pPr marL="457200" lvl="0" indent="-330200" algn="l" rtl="0">
+              <a:spcBef>
+                <a:spcPts val="0"/>
+              </a:spcBef>
+              <a:spcAft>
+                <a:spcPts val="0"/>
+              </a:spcAft>
+              <a:buSzPts val="1600"/>
+              <a:buChar char="-"/>
+            </a:pPr>
+            <a:r>
+              <a:rPr lang="en" sz="1600"/>
+              <a:t>What does the BNF for this look like?</a:t>
+            </a:r>
+            <a:endParaRPr sz="1600"/>
+          </a:p>
+          <a:p>
+            <a:pPr marL="0" lvl="0" indent="0" algn="l" rtl="0">
+              <a:spcBef>
+                <a:spcPts val="1200"/>
+              </a:spcBef>
+              <a:spcAft>
+                <a:spcPts val="1200"/>
+              </a:spcAft>
+              <a:buNone/>
+            </a:pPr>
+            <a:endParaRPr sz="1600"/>
+          </a:p>
+        </p:txBody>
+      </p:sp>
+    </p:spTree>
+  </p:cSld>
+  <p:clrMapOvr>
+    <a:masterClrMapping/>
+  </p:clrMapOvr>
+</p:sld>
+</file>
+
+<file path=ppt/slides/slide22.xml><?xml version="1.0" encoding="utf-8"?>
+<p:sld xmlns:a="http://schemas.openxmlformats.org/drawingml/2006/main" xmlns:r="http://schemas.openxmlformats.org/officeDocument/2006/relationships" xmlns:p="http://schemas.openxmlformats.org/presentationml/2006/main">
+  <p:cSld>
+    <p:spTree>
+      <p:nvGrpSpPr>
+        <p:cNvPr id="1" name="Shape 198"/>
+        <p:cNvGrpSpPr/>
+        <p:nvPr/>
+      </p:nvGrpSpPr>
+      <p:grpSpPr>
+        <a:xfrm>
+          <a:off x="0" y="0"/>
+          <a:ext cx="0" cy="0"/>
+          <a:chOff x="0" y="0"/>
+          <a:chExt cx="0" cy="0"/>
+        </a:xfrm>
+      </p:grpSpPr>
+      <p:sp>
+        <p:nvSpPr>
+          <p:cNvPr id="199" name="Google Shape;199;p31"/>
+          <p:cNvSpPr txBox="1">
+            <a:spLocks noGrp="1"/>
+          </p:cNvSpPr>
+          <p:nvPr>
+            <p:ph type="title"/>
+          </p:nvPr>
+        </p:nvSpPr>
+        <p:spPr>
+          <a:xfrm>
+            <a:off x="729450" y="1318650"/>
+            <a:ext cx="7688700" cy="535200"/>
+          </a:xfrm>
+          <a:prstGeom prst="rect">
+            <a:avLst/>
+          </a:prstGeom>
+        </p:spPr>
+        <p:txBody>
+          <a:bodyPr spcFirstLastPara="1" wrap="square" lIns="91425" tIns="91425" rIns="91425" bIns="91425" anchor="t" anchorCtr="0">
+            <a:normAutofit fontScale="90000"/>
+          </a:bodyPr>
+          <a:lstStyle/>
+          <a:p>
+            <a:pPr marL="0" lvl="0" indent="0" algn="l" rtl="0">
+              <a:spcBef>
+                <a:spcPts val="0"/>
+              </a:spcBef>
+              <a:spcAft>
+                <a:spcPts val="0"/>
+              </a:spcAft>
+              <a:buNone/>
+            </a:pPr>
+            <a:r>
+              <a:rPr lang="en"/>
+              <a:t>Solution</a:t>
+            </a:r>
+            <a:endParaRPr/>
+          </a:p>
+        </p:txBody>
+      </p:sp>
+      <p:sp>
+        <p:nvSpPr>
+          <p:cNvPr id="200" name="Google Shape;200;p31"/>
+          <p:cNvSpPr txBox="1">
+            <a:spLocks noGrp="1"/>
+          </p:cNvSpPr>
+          <p:nvPr>
+            <p:ph type="body" idx="1"/>
+          </p:nvPr>
+        </p:nvSpPr>
+        <p:spPr>
+          <a:xfrm>
+            <a:off x="729450" y="1853850"/>
+            <a:ext cx="7688700" cy="2856900"/>
+          </a:xfrm>
+          <a:prstGeom prst="rect">
+            <a:avLst/>
+          </a:prstGeom>
+        </p:spPr>
+        <p:txBody>
+          <a:bodyPr spcFirstLastPara="1" wrap="square" lIns="91425" tIns="91425" rIns="91425" bIns="91425" anchor="t" anchorCtr="0">
+            <a:normAutofit/>
+          </a:bodyPr>
+          <a:lstStyle/>
+          <a:p>
+            <a:pPr marL="0" lvl="0" indent="0" algn="l" rtl="0">
+              <a:spcBef>
+                <a:spcPts val="0"/>
+              </a:spcBef>
+              <a:spcAft>
+                <a:spcPts val="0"/>
+              </a:spcAft>
+              <a:buNone/>
+            </a:pPr>
+            <a:r>
+              <a:rPr lang="en" sz="1600"/>
+              <a:t>There are a couple of potential solutions; this is mine:</a:t>
+            </a:r>
+            <a:endParaRPr sz="1600"/>
+          </a:p>
+          <a:p>
+            <a:pPr marL="0" lvl="0" indent="0" algn="l" rtl="0">
+              <a:spcBef>
+                <a:spcPts val="1200"/>
+              </a:spcBef>
+              <a:spcAft>
+                <a:spcPts val="0"/>
+              </a:spcAft>
+              <a:buNone/>
+            </a:pPr>
+            <a:r>
+              <a:rPr lang="en" sz="1600" i="1"/>
+              <a:t>S 	=&gt;	</a:t>
+            </a:r>
+            <a:r>
+              <a:rPr lang="en" sz="1600"/>
+              <a:t>bbb</a:t>
+            </a:r>
+            <a:r>
+              <a:rPr lang="en" sz="1600" i="1"/>
+              <a:t>QR</a:t>
+            </a:r>
+            <a:endParaRPr sz="1600" i="1"/>
+          </a:p>
+          <a:p>
+            <a:pPr marL="0" lvl="0" indent="0" algn="l" rtl="0">
+              <a:spcBef>
+                <a:spcPts val="1200"/>
+              </a:spcBef>
+              <a:spcAft>
+                <a:spcPts val="0"/>
+              </a:spcAft>
+              <a:buNone/>
+            </a:pPr>
+            <a:r>
+              <a:rPr lang="en" sz="1600" i="1"/>
+              <a:t>Q	=&gt;	</a:t>
+            </a:r>
+            <a:r>
+              <a:rPr lang="en" sz="1600"/>
+              <a:t>c</a:t>
+            </a:r>
+            <a:r>
+              <a:rPr lang="en" sz="1600" i="1"/>
+              <a:t>Q</a:t>
+            </a:r>
+            <a:endParaRPr sz="1600"/>
+          </a:p>
+          <a:p>
+            <a:pPr marL="0" lvl="0" indent="0" algn="l" rtl="0">
+              <a:spcBef>
+                <a:spcPts val="1200"/>
+              </a:spcBef>
+              <a:spcAft>
+                <a:spcPts val="0"/>
+              </a:spcAft>
+              <a:buNone/>
+            </a:pPr>
+            <a:r>
+              <a:rPr lang="en" sz="1600"/>
+              <a:t>	|	c</a:t>
+            </a:r>
+            <a:endParaRPr sz="1600"/>
+          </a:p>
+          <a:p>
+            <a:pPr marL="0" lvl="0" indent="0" algn="l" rtl="0">
+              <a:spcBef>
+                <a:spcPts val="1200"/>
+              </a:spcBef>
+              <a:spcAft>
+                <a:spcPts val="0"/>
+              </a:spcAft>
+              <a:buNone/>
+            </a:pPr>
+            <a:r>
+              <a:rPr lang="en" sz="1600" i="1"/>
+              <a:t>R</a:t>
+            </a:r>
+            <a:r>
+              <a:rPr lang="en" sz="1600"/>
+              <a:t>	=&gt;	d</a:t>
+            </a:r>
+            <a:r>
+              <a:rPr lang="en" sz="1600" i="1"/>
+              <a:t>R</a:t>
+            </a:r>
+            <a:endParaRPr sz="1600" i="1"/>
+          </a:p>
+          <a:p>
+            <a:pPr marL="0" lvl="0" indent="0" algn="l" rtl="0">
+              <a:spcBef>
+                <a:spcPts val="1200"/>
+              </a:spcBef>
+              <a:spcAft>
+                <a:spcPts val="1200"/>
+              </a:spcAft>
+              <a:buNone/>
+            </a:pPr>
+            <a:r>
+              <a:rPr lang="en" sz="1600" i="1"/>
+              <a:t>	</a:t>
+            </a:r>
+            <a:r>
+              <a:rPr lang="en" sz="1600"/>
+              <a:t>|	ε</a:t>
+            </a:r>
+            <a:endParaRPr sz="1600"/>
+          </a:p>
+        </p:txBody>
+      </p:sp>
+    </p:spTree>
+  </p:cSld>
+  <p:clrMapOvr>
+    <a:masterClrMapping/>
+  </p:clrMapOvr>
+</p:sld>
+</file>
+
+<file path=ppt/slides/slide23.xml><?xml version="1.0" encoding="utf-8"?>
 <p:sld xmlns:a="http://schemas.openxmlformats.org/drawingml/2006/main" xmlns:r="http://schemas.openxmlformats.org/officeDocument/2006/relationships" xmlns:p="http://schemas.openxmlformats.org/presentationml/2006/main">
   <p:cSld>
     <p:spTree>
@@ -12405,7 +13446,7 @@
         </p:spPr>
         <p:txBody>
           <a:bodyPr spcFirstLastPara="1" wrap="square" lIns="91425" tIns="91425" rIns="91425" bIns="91425" anchor="t" anchorCtr="0">
-            <a:normAutofit/>
+            <a:normAutofit lnSpcReduction="10000"/>
           </a:bodyPr>
           <a:lstStyle/>
           <a:p>
@@ -12420,10 +13461,10 @@
               <a:buChar char="-"/>
             </a:pPr>
             <a:r>
-              <a:rPr lang="en" sz="1600"/>
-              <a:t>We’ve already seen one . . . </a:t>
-            </a:r>
-            <a:endParaRPr sz="1600"/>
+              <a:rPr lang="en" sz="1600" dirty="0"/>
+              <a:t>We’ve already discussed one . . . Regex</a:t>
+            </a:r>
+            <a:endParaRPr sz="1600" dirty="0"/>
           </a:p>
           <a:p>
             <a:pPr marL="457200" lvl="0" indent="-330200" algn="l" rtl="0">
@@ -12437,10 +13478,10 @@
               <a:buChar char="-"/>
             </a:pPr>
             <a:r>
-              <a:rPr lang="en" sz="1600"/>
+              <a:rPr lang="en" sz="1600" dirty="0"/>
               <a:t>We read them from left to right</a:t>
             </a:r>
-            <a:endParaRPr sz="1600"/>
+            <a:endParaRPr sz="1600" dirty="0"/>
           </a:p>
           <a:p>
             <a:pPr marL="457200" lvl="0" indent="-330200" algn="l" rtl="0">
@@ -12454,10 +13495,66 @@
               <a:buChar char="-"/>
             </a:pPr>
             <a:r>
-              <a:rPr lang="en" sz="1600"/>
+              <a:rPr lang="en" sz="1600" dirty="0"/>
               <a:t>Defined by anything that could be consumed by a FSM (Finite State Machine)</a:t>
             </a:r>
-            <a:endParaRPr sz="1600"/>
+          </a:p>
+          <a:p>
+            <a:pPr marL="457200" lvl="0" indent="-330200" algn="l" rtl="0">
+              <a:spcBef>
+                <a:spcPts val="0"/>
+              </a:spcBef>
+              <a:spcAft>
+                <a:spcPts val="0"/>
+              </a:spcAft>
+              <a:buSzPts val="1600"/>
+              <a:buChar char="-"/>
+            </a:pPr>
+            <a:r>
+              <a:rPr lang="en" sz="1600" dirty="0"/>
+              <a:t>Examples (in regex):</a:t>
+            </a:r>
+          </a:p>
+          <a:p>
+            <a:pPr lvl="1" indent="-330200">
+              <a:buSzPts val="1600"/>
+              <a:buChar char="-"/>
+            </a:pPr>
+            <a:r>
+              <a:rPr lang="en" sz="1400" dirty="0"/>
+              <a:t>Language that consists of any number of a’s followed by one b</a:t>
+            </a:r>
+          </a:p>
+          <a:p>
+            <a:pPr lvl="2" indent="-330200">
+              <a:buSzPts val="1600"/>
+              <a:buChar char="-"/>
+            </a:pPr>
+            <a:r>
+              <a:rPr lang="en" sz="1400" dirty="0"/>
+              <a:t>a*b</a:t>
+            </a:r>
+          </a:p>
+          <a:p>
+            <a:pPr lvl="1" indent="-330200">
+              <a:buSzPts val="1600"/>
+              <a:buChar char="-"/>
+            </a:pPr>
+            <a:r>
+              <a:rPr lang="en-US" sz="1400" dirty="0"/>
+              <a:t>Language that consists of one or more a’s followed by one b</a:t>
+            </a:r>
+          </a:p>
+          <a:p>
+            <a:pPr lvl="2" indent="-330200">
+              <a:buSzPts val="1600"/>
+              <a:buChar char="-"/>
+            </a:pPr>
+            <a:r>
+              <a:rPr lang="en-US" sz="1400" dirty="0"/>
+              <a:t>aa*b</a:t>
+            </a:r>
+            <a:endParaRPr sz="1400" dirty="0"/>
           </a:p>
         </p:txBody>
       </p:sp>
@@ -12564,10 +13661,21 @@
               <a:buChar char="-"/>
             </a:pPr>
             <a:r>
-              <a:rPr lang="en" sz="1600"/>
+              <a:rPr lang="en" sz="1600" dirty="0"/>
               <a:t>These are more complicated . . . we divide every piece of them into either ‘terminal’ or ‘non-terminal’ components</a:t>
             </a:r>
-            <a:endParaRPr sz="1600"/>
+          </a:p>
+          <a:p>
+            <a:pPr lvl="1" indent="-330200">
+              <a:buSzPts val="1600"/>
+              <a:buFont typeface="Lato"/>
+              <a:buChar char="-"/>
+            </a:pPr>
+            <a:r>
+              <a:rPr lang="en-US" sz="1400" dirty="0"/>
+              <a:t>Governed by a grammar called BNF grammar</a:t>
+            </a:r>
+            <a:endParaRPr sz="1400" dirty="0"/>
           </a:p>
           <a:p>
             <a:pPr marL="457200" lvl="0" indent="-330200" algn="l" rtl="0">
@@ -12581,10 +13689,10 @@
               <a:buChar char="-"/>
             </a:pPr>
             <a:r>
-              <a:rPr lang="en" sz="1600"/>
+              <a:rPr lang="en" sz="1600" dirty="0"/>
               <a:t>Can describe anything that a regular language can describe and more</a:t>
             </a:r>
-            <a:endParaRPr sz="1600"/>
+            <a:endParaRPr sz="1600" dirty="0"/>
           </a:p>
           <a:p>
             <a:pPr marL="457200" lvl="0" indent="-330200" algn="l" rtl="0">
@@ -12598,10 +13706,9 @@
               <a:buChar char="-"/>
             </a:pPr>
             <a:r>
-              <a:rPr lang="en" sz="1600"/>
+              <a:rPr lang="en" sz="1600" dirty="0"/>
               <a:t>Can represent most programming languages</a:t>
             </a:r>
-            <a:endParaRPr sz="1600"/>
           </a:p>
         </p:txBody>
       </p:sp>
@@ -12708,10 +13815,10 @@
               <a:buChar char="-"/>
             </a:pPr>
             <a:r>
-              <a:rPr lang="en" sz="1600"/>
+              <a:rPr lang="en" sz="1600" dirty="0"/>
               <a:t>Complicated, confusing combination of regular and context free languages in the sense that they utilize finite state machines with terminal and non-terminal states</a:t>
             </a:r>
-            <a:endParaRPr sz="1600"/>
+            <a:endParaRPr sz="1600" dirty="0"/>
           </a:p>
           <a:p>
             <a:pPr marL="457200" lvl="0" indent="-330200" algn="l" rtl="0">
@@ -12725,10 +13832,10 @@
               <a:buChar char="-"/>
             </a:pPr>
             <a:r>
-              <a:rPr lang="en" sz="1600"/>
+              <a:rPr lang="en" sz="1600" dirty="0"/>
               <a:t>Can describe anything that a context free language can describe and more</a:t>
             </a:r>
-            <a:endParaRPr sz="1600"/>
+            <a:endParaRPr sz="1600" dirty="0"/>
           </a:p>
           <a:p>
             <a:pPr marL="457200" lvl="0" indent="-330200" algn="l" rtl="0">
@@ -12742,10 +13849,14 @@
               <a:buChar char="-"/>
             </a:pPr>
             <a:r>
-              <a:rPr lang="en" sz="1600"/>
-              <a:t>Completely beyond the scope of this course</a:t>
-            </a:r>
-            <a:endParaRPr sz="1600"/>
+              <a:rPr lang="en" sz="1600" i="1" dirty="0"/>
+              <a:t>Completely</a:t>
+            </a:r>
+            <a:r>
+              <a:rPr lang="en" sz="1600" dirty="0"/>
+              <a:t> beyond the scope of this course</a:t>
+            </a:r>
+            <a:endParaRPr sz="1600" dirty="0"/>
           </a:p>
         </p:txBody>
       </p:sp>
@@ -12758,6 +13869,376 @@
 </file>
 
 <file path=ppt/slides/slide7.xml><?xml version="1.0" encoding="utf-8"?>
+<p:sld xmlns:a="http://schemas.openxmlformats.org/drawingml/2006/main" xmlns:r="http://schemas.openxmlformats.org/officeDocument/2006/relationships" xmlns:p="http://schemas.openxmlformats.org/presentationml/2006/main">
+  <p:cSld>
+    <p:spTree>
+      <p:nvGrpSpPr>
+        <p:cNvPr id="1" name=""/>
+        <p:cNvGrpSpPr/>
+        <p:nvPr/>
+      </p:nvGrpSpPr>
+      <p:grpSpPr>
+        <a:xfrm>
+          <a:off x="0" y="0"/>
+          <a:ext cx="0" cy="0"/>
+          <a:chOff x="0" y="0"/>
+          <a:chExt cx="0" cy="0"/>
+        </a:xfrm>
+      </p:grpSpPr>
+      <p:sp>
+        <p:nvSpPr>
+          <p:cNvPr id="7" name="Oval 6">
+            <a:extLst>
+              <a:ext uri="{FF2B5EF4-FFF2-40B4-BE49-F238E27FC236}">
+                <a16:creationId xmlns:a16="http://schemas.microsoft.com/office/drawing/2014/main" id="{D8BF99E1-3A3D-798D-1DB9-C9EF28CEB961}"/>
+              </a:ext>
+            </a:extLst>
+          </p:cNvPr>
+          <p:cNvSpPr/>
+          <p:nvPr/>
+        </p:nvSpPr>
+        <p:spPr>
+          <a:xfrm>
+            <a:off x="2931737" y="1807948"/>
+            <a:ext cx="3120272" cy="2999722"/>
+          </a:xfrm>
+          <a:prstGeom prst="ellipse">
+            <a:avLst/>
+          </a:prstGeom>
+          <a:solidFill>
+            <a:srgbClr val="00B0F0"/>
+          </a:solidFill>
+        </p:spPr>
+        <p:style>
+          <a:lnRef idx="2">
+            <a:schemeClr val="accent1">
+              <a:shade val="15000"/>
+            </a:schemeClr>
+          </a:lnRef>
+          <a:fillRef idx="1">
+            <a:schemeClr val="accent1"/>
+          </a:fillRef>
+          <a:effectRef idx="0">
+            <a:schemeClr val="accent1"/>
+          </a:effectRef>
+          <a:fontRef idx="minor">
+            <a:schemeClr val="lt1"/>
+          </a:fontRef>
+        </p:style>
+        <p:txBody>
+          <a:bodyPr rtlCol="0" anchor="ctr"/>
+          <a:lstStyle/>
+          <a:p>
+            <a:pPr algn="ctr"/>
+            <a:endParaRPr lang="en-US" dirty="0"/>
+          </a:p>
+        </p:txBody>
+      </p:sp>
+      <p:sp>
+        <p:nvSpPr>
+          <p:cNvPr id="5" name="Oval 4">
+            <a:extLst>
+              <a:ext uri="{FF2B5EF4-FFF2-40B4-BE49-F238E27FC236}">
+                <a16:creationId xmlns:a16="http://schemas.microsoft.com/office/drawing/2014/main" id="{81A2435C-A0B5-C7A0-D528-3677F3F10ADD}"/>
+              </a:ext>
+            </a:extLst>
+          </p:cNvPr>
+          <p:cNvSpPr/>
+          <p:nvPr/>
+        </p:nvSpPr>
+        <p:spPr>
+          <a:xfrm>
+            <a:off x="3473713" y="1807949"/>
+            <a:ext cx="1997573" cy="1915640"/>
+          </a:xfrm>
+          <a:prstGeom prst="ellipse">
+            <a:avLst/>
+          </a:prstGeom>
+          <a:solidFill>
+            <a:srgbClr val="92D050"/>
+          </a:solidFill>
+        </p:spPr>
+        <p:style>
+          <a:lnRef idx="2">
+            <a:schemeClr val="accent1">
+              <a:shade val="15000"/>
+            </a:schemeClr>
+          </a:lnRef>
+          <a:fillRef idx="1">
+            <a:schemeClr val="accent1"/>
+          </a:fillRef>
+          <a:effectRef idx="0">
+            <a:schemeClr val="accent1"/>
+          </a:effectRef>
+          <a:fontRef idx="minor">
+            <a:schemeClr val="lt1"/>
+          </a:fontRef>
+        </p:style>
+        <p:txBody>
+          <a:bodyPr rtlCol="0" anchor="ctr"/>
+          <a:lstStyle/>
+          <a:p>
+            <a:pPr algn="ctr"/>
+            <a:endParaRPr lang="en-US" dirty="0"/>
+          </a:p>
+        </p:txBody>
+      </p:sp>
+      <p:sp>
+        <p:nvSpPr>
+          <p:cNvPr id="2" name="Title 1">
+            <a:extLst>
+              <a:ext uri="{FF2B5EF4-FFF2-40B4-BE49-F238E27FC236}">
+                <a16:creationId xmlns:a16="http://schemas.microsoft.com/office/drawing/2014/main" id="{A426DA25-E22E-D828-6356-EFFF779DA9FD}"/>
+              </a:ext>
+            </a:extLst>
+          </p:cNvPr>
+          <p:cNvSpPr>
+            <a:spLocks noGrp="1"/>
+          </p:cNvSpPr>
+          <p:nvPr>
+            <p:ph type="title"/>
+          </p:nvPr>
+        </p:nvSpPr>
+        <p:spPr/>
+        <p:txBody>
+          <a:bodyPr>
+            <a:normAutofit fontScale="90000"/>
+          </a:bodyPr>
+          <a:lstStyle/>
+          <a:p>
+            <a:r>
+              <a:rPr lang="en-US" dirty="0"/>
+              <a:t>Language Hierarchy</a:t>
+            </a:r>
+          </a:p>
+        </p:txBody>
+      </p:sp>
+      <p:sp>
+        <p:nvSpPr>
+          <p:cNvPr id="4" name="Oval 3">
+            <a:extLst>
+              <a:ext uri="{FF2B5EF4-FFF2-40B4-BE49-F238E27FC236}">
+                <a16:creationId xmlns:a16="http://schemas.microsoft.com/office/drawing/2014/main" id="{05541C18-BAE9-DF0F-23C0-9898FDB57CA5}"/>
+              </a:ext>
+            </a:extLst>
+          </p:cNvPr>
+          <p:cNvSpPr/>
+          <p:nvPr/>
+        </p:nvSpPr>
+        <p:spPr>
+          <a:xfrm>
+            <a:off x="3714278" y="1807948"/>
+            <a:ext cx="1530297" cy="1025936"/>
+          </a:xfrm>
+          <a:prstGeom prst="ellipse">
+            <a:avLst/>
+          </a:prstGeom>
+          <a:solidFill>
+            <a:srgbClr val="FFFF00"/>
+          </a:solidFill>
+        </p:spPr>
+        <p:style>
+          <a:lnRef idx="2">
+            <a:schemeClr val="accent1">
+              <a:shade val="15000"/>
+            </a:schemeClr>
+          </a:lnRef>
+          <a:fillRef idx="1">
+            <a:schemeClr val="accent1"/>
+          </a:fillRef>
+          <a:effectRef idx="0">
+            <a:schemeClr val="accent1"/>
+          </a:effectRef>
+          <a:fontRef idx="minor">
+            <a:schemeClr val="lt1"/>
+          </a:fontRef>
+        </p:style>
+        <p:txBody>
+          <a:bodyPr rtlCol="0" anchor="ctr"/>
+          <a:lstStyle/>
+          <a:p>
+            <a:pPr algn="ctr"/>
+            <a:r>
+              <a:rPr lang="en-US" dirty="0">
+                <a:solidFill>
+                  <a:schemeClr val="bg2"/>
+                </a:solidFill>
+              </a:rPr>
+              <a:t>Regular Languages</a:t>
+            </a:r>
+          </a:p>
+        </p:txBody>
+      </p:sp>
+      <p:sp>
+        <p:nvSpPr>
+          <p:cNvPr id="6" name="TextBox 5">
+            <a:extLst>
+              <a:ext uri="{FF2B5EF4-FFF2-40B4-BE49-F238E27FC236}">
+                <a16:creationId xmlns:a16="http://schemas.microsoft.com/office/drawing/2014/main" id="{DFF47CB5-1272-BD56-92CD-F0EBAD35EBE2}"/>
+              </a:ext>
+            </a:extLst>
+          </p:cNvPr>
+          <p:cNvSpPr txBox="1"/>
+          <p:nvPr/>
+        </p:nvSpPr>
+        <p:spPr>
+          <a:xfrm>
+            <a:off x="3819549" y="2922309"/>
+            <a:ext cx="1319753" cy="523220"/>
+          </a:xfrm>
+          <a:prstGeom prst="rect">
+            <a:avLst/>
+          </a:prstGeom>
+          <a:noFill/>
+        </p:spPr>
+        <p:txBody>
+          <a:bodyPr wrap="square" rtlCol="0">
+            <a:spAutoFit/>
+          </a:bodyPr>
+          <a:lstStyle/>
+          <a:p>
+            <a:pPr algn="ctr"/>
+            <a:r>
+              <a:rPr lang="en-US" dirty="0"/>
+              <a:t>Context Free Languages</a:t>
+            </a:r>
+          </a:p>
+        </p:txBody>
+      </p:sp>
+      <p:sp>
+        <p:nvSpPr>
+          <p:cNvPr id="8" name="TextBox 7">
+            <a:extLst>
+              <a:ext uri="{FF2B5EF4-FFF2-40B4-BE49-F238E27FC236}">
+                <a16:creationId xmlns:a16="http://schemas.microsoft.com/office/drawing/2014/main" id="{36213B6C-4504-3D16-7D48-36185308D928}"/>
+              </a:ext>
+            </a:extLst>
+          </p:cNvPr>
+          <p:cNvSpPr txBox="1"/>
+          <p:nvPr/>
+        </p:nvSpPr>
+        <p:spPr>
+          <a:xfrm>
+            <a:off x="3624087" y="3934827"/>
+            <a:ext cx="1696824" cy="523220"/>
+          </a:xfrm>
+          <a:prstGeom prst="rect">
+            <a:avLst/>
+          </a:prstGeom>
+          <a:noFill/>
+        </p:spPr>
+        <p:txBody>
+          <a:bodyPr wrap="square" rtlCol="0">
+            <a:spAutoFit/>
+          </a:bodyPr>
+          <a:lstStyle/>
+          <a:p>
+            <a:pPr algn="ctr"/>
+            <a:r>
+              <a:rPr lang="en-US" dirty="0"/>
+              <a:t>Context Sensitive Languages</a:t>
+            </a:r>
+          </a:p>
+        </p:txBody>
+      </p:sp>
+      <p:sp>
+        <p:nvSpPr>
+          <p:cNvPr id="9" name="Down Arrow 8">
+            <a:extLst>
+              <a:ext uri="{FF2B5EF4-FFF2-40B4-BE49-F238E27FC236}">
+                <a16:creationId xmlns:a16="http://schemas.microsoft.com/office/drawing/2014/main" id="{881C68AB-D3B6-FD07-50EF-F9DFC75F4936}"/>
+              </a:ext>
+            </a:extLst>
+          </p:cNvPr>
+          <p:cNvSpPr/>
+          <p:nvPr/>
+        </p:nvSpPr>
+        <p:spPr>
+          <a:xfrm rot="5400000">
+            <a:off x="5940677" y="2059718"/>
+            <a:ext cx="890769" cy="1914835"/>
+          </a:xfrm>
+          <a:prstGeom prst="downArrow">
+            <a:avLst/>
+          </a:prstGeom>
+          <a:solidFill>
+            <a:srgbClr val="FF0000"/>
+          </a:solidFill>
+        </p:spPr>
+        <p:style>
+          <a:lnRef idx="2">
+            <a:schemeClr val="accent1">
+              <a:shade val="15000"/>
+            </a:schemeClr>
+          </a:lnRef>
+          <a:fillRef idx="1">
+            <a:schemeClr val="accent1"/>
+          </a:fillRef>
+          <a:effectRef idx="0">
+            <a:schemeClr val="accent1"/>
+          </a:effectRef>
+          <a:fontRef idx="minor">
+            <a:schemeClr val="lt1"/>
+          </a:fontRef>
+        </p:style>
+        <p:txBody>
+          <a:bodyPr rtlCol="0" anchor="ctr"/>
+          <a:lstStyle/>
+          <a:p>
+            <a:pPr algn="ctr"/>
+            <a:endParaRPr lang="en-US"/>
+          </a:p>
+        </p:txBody>
+      </p:sp>
+      <p:sp>
+        <p:nvSpPr>
+          <p:cNvPr id="10" name="TextBox 9">
+            <a:extLst>
+              <a:ext uri="{FF2B5EF4-FFF2-40B4-BE49-F238E27FC236}">
+                <a16:creationId xmlns:a16="http://schemas.microsoft.com/office/drawing/2014/main" id="{1E946FE0-EDFF-DE22-880D-20F19B5351D7}"/>
+              </a:ext>
+            </a:extLst>
+          </p:cNvPr>
+          <p:cNvSpPr txBox="1"/>
+          <p:nvPr/>
+        </p:nvSpPr>
+        <p:spPr>
+          <a:xfrm>
+            <a:off x="7445085" y="2876142"/>
+            <a:ext cx="1180131" cy="307777"/>
+          </a:xfrm>
+          <a:prstGeom prst="rect">
+            <a:avLst/>
+          </a:prstGeom>
+          <a:noFill/>
+        </p:spPr>
+        <p:txBody>
+          <a:bodyPr wrap="none" rtlCol="0">
+            <a:spAutoFit/>
+          </a:bodyPr>
+          <a:lstStyle/>
+          <a:p>
+            <a:r>
+              <a:rPr lang="en-US" dirty="0"/>
+              <a:t>We live here</a:t>
+            </a:r>
+          </a:p>
+        </p:txBody>
+      </p:sp>
+    </p:spTree>
+    <p:extLst>
+      <p:ext uri="{BB962C8B-B14F-4D97-AF65-F5344CB8AC3E}">
+        <p14:creationId xmlns:p14="http://schemas.microsoft.com/office/powerpoint/2010/main" val="165319109"/>
+      </p:ext>
+    </p:extLst>
+  </p:cSld>
+  <p:clrMapOvr>
+    <a:masterClrMapping/>
+  </p:clrMapOvr>
+</p:sld>
+</file>
+
+<file path=ppt/slides/slide8.xml><?xml version="1.0" encoding="utf-8"?>
 <p:sld xmlns:a="http://schemas.openxmlformats.org/drawingml/2006/main" xmlns:r="http://schemas.openxmlformats.org/officeDocument/2006/relationships" xmlns:p="http://schemas.openxmlformats.org/presentationml/2006/main">
   <p:cSld>
     <p:spTree>
@@ -12969,7 +14450,7 @@
 </p:sld>
 </file>
 
-<file path=ppt/slides/slide8.xml><?xml version="1.0" encoding="utf-8"?>
+<file path=ppt/slides/slide9.xml><?xml version="1.0" encoding="utf-8"?>
 <p:sld xmlns:a="http://schemas.openxmlformats.org/drawingml/2006/main" xmlns:r="http://schemas.openxmlformats.org/officeDocument/2006/relationships" xmlns:p="http://schemas.openxmlformats.org/presentationml/2006/main">
   <p:cSld>
     <p:spTree>
@@ -13021,10 +14502,10 @@
               <a:buNone/>
             </a:pPr>
             <a:r>
-              <a:rPr lang="en"/>
-              <a:t>BNG Grammar (continued)</a:t>
-            </a:r>
-            <a:endParaRPr/>
+              <a:rPr lang="en" dirty="0"/>
+              <a:t>BNF Grammar (continued)</a:t>
+            </a:r>
+            <a:endParaRPr dirty="0"/>
           </a:p>
         </p:txBody>
       </p:sp>
@@ -13041,7 +14522,7 @@
         <p:spPr>
           <a:xfrm>
             <a:off x="729450" y="2078875"/>
-            <a:ext cx="7688700" cy="2261100"/>
+            <a:ext cx="7688700" cy="2643954"/>
           </a:xfrm>
           <a:prstGeom prst="rect">
             <a:avLst/>
@@ -13049,7 +14530,7 @@
         </p:spPr>
         <p:txBody>
           <a:bodyPr spcFirstLastPara="1" wrap="square" lIns="91425" tIns="91425" rIns="91425" bIns="91425" anchor="t" anchorCtr="0">
-            <a:normAutofit/>
+            <a:normAutofit lnSpcReduction="10000"/>
           </a:bodyPr>
           <a:lstStyle/>
           <a:p>
@@ -13064,10 +14545,10 @@
               <a:buChar char="-"/>
             </a:pPr>
             <a:r>
-              <a:rPr lang="en" sz="1600"/>
+              <a:rPr lang="en" sz="1600" dirty="0"/>
               <a:t>Meta-variables</a:t>
             </a:r>
-            <a:endParaRPr sz="1600"/>
+            <a:endParaRPr sz="1600" dirty="0"/>
           </a:p>
           <a:p>
             <a:pPr marL="914400" lvl="1" indent="-330200" algn="l" rtl="0">
@@ -13081,10 +14562,10 @@
               <a:buChar char="-"/>
             </a:pPr>
             <a:r>
-              <a:rPr lang="en" sz="1600"/>
+              <a:rPr lang="en" sz="1600" dirty="0"/>
               <a:t>A fancy way to describe normal variable naming conventions</a:t>
             </a:r>
-            <a:endParaRPr sz="1600"/>
+            <a:endParaRPr sz="1600" dirty="0"/>
           </a:p>
           <a:p>
             <a:pPr marL="457200" lvl="0" indent="-330200" algn="l" rtl="0">
@@ -13098,10 +14579,10 @@
               <a:buChar char="-"/>
             </a:pPr>
             <a:r>
-              <a:rPr lang="en" sz="1600"/>
+              <a:rPr lang="en" sz="1600" dirty="0"/>
               <a:t>Terminal</a:t>
             </a:r>
-            <a:endParaRPr sz="1600"/>
+            <a:endParaRPr sz="1600" dirty="0"/>
           </a:p>
           <a:p>
             <a:pPr marL="914400" lvl="1" indent="-330200" algn="l" rtl="0">
@@ -13115,10 +14596,10 @@
               <a:buChar char="-"/>
             </a:pPr>
             <a:r>
-              <a:rPr lang="en" sz="1600"/>
+              <a:rPr lang="en" sz="1600" dirty="0"/>
               <a:t>Everything else</a:t>
             </a:r>
-            <a:endParaRPr sz="1600"/>
+            <a:endParaRPr sz="1600" dirty="0"/>
           </a:p>
           <a:p>
             <a:pPr marL="914400" lvl="1" indent="-330200" algn="l" rtl="0">
@@ -13132,336 +14613,56 @@
               <a:buChar char="-"/>
             </a:pPr>
             <a:r>
-              <a:rPr lang="en" sz="1600"/>
+              <a:rPr lang="en" sz="1600" dirty="0"/>
               <a:t>These are in terms of our ‘object’ language</a:t>
             </a:r>
-            <a:endParaRPr sz="1600"/>
-          </a:p>
-        </p:txBody>
-      </p:sp>
-    </p:spTree>
-  </p:cSld>
-  <p:clrMapOvr>
-    <a:masterClrMapping/>
-  </p:clrMapOvr>
-</p:sld>
-</file>
-
-<file path=ppt/slides/slide9.xml><?xml version="1.0" encoding="utf-8"?>
-<p:sld xmlns:a="http://schemas.openxmlformats.org/drawingml/2006/main" xmlns:r="http://schemas.openxmlformats.org/officeDocument/2006/relationships" xmlns:p="http://schemas.openxmlformats.org/presentationml/2006/main">
-  <p:cSld>
-    <p:spTree>
-      <p:nvGrpSpPr>
-        <p:cNvPr id="1" name="Shape 133"/>
-        <p:cNvGrpSpPr/>
-        <p:nvPr/>
-      </p:nvGrpSpPr>
-      <p:grpSpPr>
-        <a:xfrm>
-          <a:off x="0" y="0"/>
-          <a:ext cx="0" cy="0"/>
-          <a:chOff x="0" y="0"/>
-          <a:chExt cx="0" cy="0"/>
-        </a:xfrm>
-      </p:grpSpPr>
-      <p:sp>
-        <p:nvSpPr>
-          <p:cNvPr id="134" name="Google Shape;134;p21"/>
-          <p:cNvSpPr txBox="1">
-            <a:spLocks noGrp="1"/>
-          </p:cNvSpPr>
-          <p:nvPr>
-            <p:ph type="title"/>
-          </p:nvPr>
-        </p:nvSpPr>
-        <p:spPr>
-          <a:xfrm>
-            <a:off x="729450" y="1318650"/>
-            <a:ext cx="7688700" cy="535200"/>
-          </a:xfrm>
-          <a:prstGeom prst="rect">
-            <a:avLst/>
-          </a:prstGeom>
-        </p:spPr>
-        <p:txBody>
-          <a:bodyPr spcFirstLastPara="1" wrap="square" lIns="91425" tIns="91425" rIns="91425" bIns="91425" anchor="t" anchorCtr="0">
-            <a:normAutofit fontScale="90000"/>
-          </a:bodyPr>
-          <a:lstStyle/>
-          <a:p>
-            <a:pPr marL="0" lvl="0" indent="0" algn="l" rtl="0">
-              <a:spcBef>
-                <a:spcPts val="0"/>
-              </a:spcBef>
-              <a:spcAft>
-                <a:spcPts val="0"/>
-              </a:spcAft>
-              <a:buNone/>
-            </a:pPr>
-            <a:r>
-              <a:rPr lang="en"/>
-              <a:t>An Example: Bits</a:t>
-            </a:r>
-            <a:endParaRPr/>
-          </a:p>
-        </p:txBody>
-      </p:sp>
-      <p:sp>
-        <p:nvSpPr>
-          <p:cNvPr id="135" name="Google Shape;135;p21"/>
-          <p:cNvSpPr txBox="1">
-            <a:spLocks noGrp="1"/>
-          </p:cNvSpPr>
-          <p:nvPr>
-            <p:ph type="body" idx="1"/>
-          </p:nvPr>
-        </p:nvSpPr>
-        <p:spPr>
-          <a:xfrm>
-            <a:off x="729449" y="2078875"/>
-            <a:ext cx="2227395" cy="2261100"/>
-          </a:xfrm>
-          <a:prstGeom prst="rect">
-            <a:avLst/>
-          </a:prstGeom>
-        </p:spPr>
-        <p:txBody>
-          <a:bodyPr spcFirstLastPara="1" wrap="square" lIns="91425" tIns="91425" rIns="91425" bIns="91425" anchor="t" anchorCtr="0">
-            <a:normAutofit/>
-          </a:bodyPr>
-          <a:lstStyle/>
-          <a:p>
-            <a:pPr marL="0" lvl="0" indent="0" algn="l" rtl="0">
-              <a:spcBef>
-                <a:spcPts val="0"/>
-              </a:spcBef>
-              <a:spcAft>
-                <a:spcPts val="0"/>
-              </a:spcAft>
-              <a:buNone/>
-            </a:pPr>
-            <a:r>
-              <a:rPr lang="en" sz="1600" i="1" dirty="0"/>
-              <a:t>Bit</a:t>
-            </a:r>
+          </a:p>
+          <a:p>
+            <a:pPr indent="-330200">
+              <a:buSzPts val="1600"/>
+              <a:buChar char="-"/>
+            </a:pPr>
+            <a:r>
+              <a:rPr lang="en" sz="1800" dirty="0"/>
+              <a:t>Sentence</a:t>
+            </a:r>
+          </a:p>
+          <a:p>
+            <a:pPr lvl="1" indent="-330200">
+              <a:buSzPts val="1600"/>
+              <a:buChar char="-"/>
+            </a:pPr>
             <a:r>
               <a:rPr lang="en" sz="1600" dirty="0"/>
-              <a:t> 	=&gt; 	0</a:t>
-            </a:r>
-          </a:p>
-          <a:p>
-            <a:pPr marL="0" lvl="0" indent="0" algn="l" rtl="0">
-              <a:spcBef>
-                <a:spcPts val="0"/>
-              </a:spcBef>
-              <a:spcAft>
-                <a:spcPts val="0"/>
-              </a:spcAft>
-              <a:buNone/>
-            </a:pPr>
-            <a:r>
-              <a:rPr lang="en" sz="1600" dirty="0"/>
-              <a:t>	|	1</a:t>
-            </a:r>
+              <a:t>String that can be created with our BNF grammar</a:t>
+            </a:r>
+          </a:p>
+          <a:p>
+            <a:pPr indent="-330200">
+              <a:buSzPts val="1600"/>
+              <a:buChar char="-"/>
+            </a:pPr>
+            <a:r>
+              <a:rPr lang="en-US" sz="1800" dirty="0"/>
+              <a:t>Language</a:t>
+            </a:r>
+          </a:p>
+          <a:p>
+            <a:pPr lvl="1" indent="-330200">
+              <a:buSzPts val="1600"/>
+              <a:buChar char="-"/>
+            </a:pPr>
+            <a:r>
+              <a:rPr lang="en-US" sz="1600" dirty="0"/>
+              <a:t>Consists of all possible sentences that our BNF can be used to create</a:t>
+            </a:r>
+          </a:p>
+          <a:p>
+            <a:pPr lvl="1" indent="-330200">
+              <a:buSzPts val="1600"/>
+              <a:buChar char="-"/>
+            </a:pPr>
             <a:endParaRPr sz="1600" dirty="0"/>
-          </a:p>
-          <a:p>
-            <a:pPr marL="0" lvl="0" indent="0" algn="l" rtl="0">
-              <a:spcBef>
-                <a:spcPts val="1200"/>
-              </a:spcBef>
-              <a:spcAft>
-                <a:spcPts val="0"/>
-              </a:spcAft>
-              <a:buNone/>
-            </a:pPr>
-            <a:endParaRPr sz="1600" dirty="0"/>
-          </a:p>
-          <a:p>
-            <a:pPr marL="0" lvl="0" indent="0" algn="l" rtl="0">
-              <a:spcBef>
-                <a:spcPts val="1200"/>
-              </a:spcBef>
-              <a:spcAft>
-                <a:spcPts val="1200"/>
-              </a:spcAft>
-              <a:buNone/>
-            </a:pPr>
-            <a:endParaRPr sz="1600" dirty="0"/>
-          </a:p>
-        </p:txBody>
-      </p:sp>
-      <p:sp>
-        <p:nvSpPr>
-          <p:cNvPr id="136" name="Google Shape;136;p21"/>
-          <p:cNvSpPr txBox="1"/>
-          <p:nvPr/>
-        </p:nvSpPr>
-        <p:spPr>
-          <a:xfrm>
-            <a:off x="4196750" y="2142825"/>
-            <a:ext cx="4221300" cy="2646300"/>
-          </a:xfrm>
-          <a:prstGeom prst="rect">
-            <a:avLst/>
-          </a:prstGeom>
-          <a:noFill/>
-          <a:ln>
-            <a:noFill/>
-          </a:ln>
-        </p:spPr>
-        <p:txBody>
-          <a:bodyPr spcFirstLastPara="1" wrap="square" lIns="91425" tIns="91425" rIns="91425" bIns="91425" anchor="t" anchorCtr="0">
-            <a:noAutofit/>
-          </a:bodyPr>
-          <a:lstStyle/>
-          <a:p>
-            <a:pPr marL="457200" lvl="0" indent="-330200" algn="l" rtl="0">
-              <a:spcBef>
-                <a:spcPts val="0"/>
-              </a:spcBef>
-              <a:spcAft>
-                <a:spcPts val="0"/>
-              </a:spcAft>
-              <a:buClr>
-                <a:schemeClr val="accent1"/>
-              </a:buClr>
-              <a:buSzPts val="1600"/>
-              <a:buFont typeface="Lato"/>
-              <a:buChar char="-"/>
-            </a:pPr>
-            <a:r>
-              <a:rPr lang="en" sz="1600">
-                <a:solidFill>
-                  <a:schemeClr val="accent1"/>
-                </a:solidFill>
-                <a:latin typeface="Lato"/>
-                <a:ea typeface="Lato"/>
-                <a:cs typeface="Lato"/>
-                <a:sym typeface="Lato"/>
-              </a:rPr>
-              <a:t>Only one rule</a:t>
-            </a:r>
-            <a:endParaRPr sz="1600">
-              <a:solidFill>
-                <a:schemeClr val="accent1"/>
-              </a:solidFill>
-              <a:latin typeface="Lato"/>
-              <a:ea typeface="Lato"/>
-              <a:cs typeface="Lato"/>
-              <a:sym typeface="Lato"/>
-            </a:endParaRPr>
-          </a:p>
-          <a:p>
-            <a:pPr marL="457200" lvl="0" indent="-330200" algn="l" rtl="0">
-              <a:spcBef>
-                <a:spcPts val="0"/>
-              </a:spcBef>
-              <a:spcAft>
-                <a:spcPts val="0"/>
-              </a:spcAft>
-              <a:buClr>
-                <a:schemeClr val="accent1"/>
-              </a:buClr>
-              <a:buSzPts val="1600"/>
-              <a:buFont typeface="Lato"/>
-              <a:buChar char="-"/>
-            </a:pPr>
-            <a:r>
-              <a:rPr lang="en" sz="1600">
-                <a:solidFill>
-                  <a:schemeClr val="accent1"/>
-                </a:solidFill>
-                <a:latin typeface="Lato"/>
-                <a:ea typeface="Lato"/>
-                <a:cs typeface="Lato"/>
-                <a:sym typeface="Lato"/>
-              </a:rPr>
-              <a:t>One non-terminal</a:t>
-            </a:r>
-            <a:endParaRPr sz="1600">
-              <a:solidFill>
-                <a:schemeClr val="accent1"/>
-              </a:solidFill>
-              <a:latin typeface="Lato"/>
-              <a:ea typeface="Lato"/>
-              <a:cs typeface="Lato"/>
-              <a:sym typeface="Lato"/>
-            </a:endParaRPr>
-          </a:p>
-          <a:p>
-            <a:pPr marL="457200" lvl="0" indent="-330200" algn="l" rtl="0">
-              <a:spcBef>
-                <a:spcPts val="0"/>
-              </a:spcBef>
-              <a:spcAft>
-                <a:spcPts val="0"/>
-              </a:spcAft>
-              <a:buClr>
-                <a:schemeClr val="accent1"/>
-              </a:buClr>
-              <a:buSzPts val="1600"/>
-              <a:buFont typeface="Lato"/>
-              <a:buChar char="-"/>
-            </a:pPr>
-            <a:r>
-              <a:rPr lang="en" sz="1600">
-                <a:solidFill>
-                  <a:schemeClr val="accent1"/>
-                </a:solidFill>
-                <a:latin typeface="Lato"/>
-                <a:ea typeface="Lato"/>
-                <a:cs typeface="Lato"/>
-                <a:sym typeface="Lato"/>
-              </a:rPr>
-              <a:t>Two terminals</a:t>
-            </a:r>
-            <a:endParaRPr sz="1600">
-              <a:solidFill>
-                <a:schemeClr val="accent1"/>
-              </a:solidFill>
-              <a:latin typeface="Lato"/>
-              <a:ea typeface="Lato"/>
-              <a:cs typeface="Lato"/>
-              <a:sym typeface="Lato"/>
-            </a:endParaRPr>
-          </a:p>
-          <a:p>
-            <a:pPr marL="457200" lvl="0" indent="-330200" algn="l" rtl="0">
-              <a:spcBef>
-                <a:spcPts val="0"/>
-              </a:spcBef>
-              <a:spcAft>
-                <a:spcPts val="0"/>
-              </a:spcAft>
-              <a:buClr>
-                <a:schemeClr val="accent1"/>
-              </a:buClr>
-              <a:buSzPts val="1600"/>
-              <a:buFont typeface="Lato"/>
-              <a:buChar char="-"/>
-            </a:pPr>
-            <a:r>
-              <a:rPr lang="en" sz="1600">
-                <a:solidFill>
-                  <a:schemeClr val="accent1"/>
-                </a:solidFill>
-                <a:latin typeface="Lato"/>
-                <a:ea typeface="Lato"/>
-                <a:cs typeface="Lato"/>
-                <a:sym typeface="Lato"/>
-              </a:rPr>
-              <a:t>How many sentences can we make with this grammar?</a:t>
-            </a:r>
-            <a:endParaRPr sz="1600">
-              <a:solidFill>
-                <a:schemeClr val="accent1"/>
-              </a:solidFill>
-              <a:latin typeface="Lato"/>
-              <a:ea typeface="Lato"/>
-              <a:cs typeface="Lato"/>
-              <a:sym typeface="Lato"/>
-            </a:endParaRPr>
           </a:p>
         </p:txBody>
       </p:sp>

</xml_diff>